<commit_message>
doc: regenerate the showcase from the denser example decks
</commit_message>
<xml_diff>
--- a/examples/showcase/decks/balpyo-intro/balpyo-소개.pptx
+++ b/examples/showcase/decks/balpyo-intro/balpyo-소개.pptx
@@ -673,7 +673,7 @@
           <a:lstStyle/>
           <a:p>
             <a:r>
-              <a:t>"열리는 파일"과 "편집 가능한 파일"의 차이가 여기서 갈린다.</a:t>
+              <a:t>PowerPoint에서 글자를 고칠 수 있고, 표는 셀을 클릭해 행을 더할 수 있다. "열리는 파일"과 "편집 가능한 파일"의 차이가 여기서 갈린다.</a:t>
             </a:r>
           </a:p>
         </p:txBody>
@@ -1404,8 +1404,8 @@
         </p:nvSpPr>
         <p:spPr>
           <a:xfrm>
-            <a:off x="609600" y="2937570"/>
-            <a:ext cx="10972800" cy="514350"/>
+            <a:off x="609600" y="2400300"/>
+            <a:ext cx="10972800" cy="1485900"/>
           </a:xfrm>
           <a:prstGeom prst="rect">
             <a:avLst/>
@@ -1423,11 +1423,11 @@
           <a:p>
             <a:pPr algn="ctr">
               <a:lnSpc>
-                <a:spcPts val="4050"/>
-              </a:lnSpc>
-            </a:pPr>
-            <a:r>
-              <a:rPr sz="2700" b="0">
+                <a:spcPts val="5850"/>
+              </a:lnSpc>
+            </a:pPr>
+            <a:r>
+              <a:rPr sz="3900" b="0">
                 <a:solidFill>
                   <a:schemeClr val="tx1"/>
                 </a:solidFill>
@@ -1447,8 +1447,8 @@
         </p:nvSpPr>
         <p:spPr>
           <a:xfrm>
-            <a:off x="609600" y="3680520"/>
-            <a:ext cx="10972800" cy="239911"/>
+            <a:off x="609600" y="4114800"/>
+            <a:ext cx="10972800" cy="342900"/>
           </a:xfrm>
           <a:prstGeom prst="rect">
             <a:avLst/>
@@ -1466,11 +1466,11 @@
           <a:p>
             <a:pPr algn="ctr">
               <a:lnSpc>
-                <a:spcPts val="1890"/>
-              </a:lnSpc>
-            </a:pPr>
-            <a:r>
-              <a:rPr sz="1350" b="0">
+                <a:spcPts val="2700"/>
+              </a:lnSpc>
+            </a:pPr>
+            <a:r>
+              <a:rPr sz="1800" b="0">
                 <a:solidFill>
                   <a:schemeClr val="tx2"/>
                 </a:solidFill>
@@ -1554,14 +1554,45 @@
       </p:sp>
       <p:sp>
         <p:nvSpPr>
-          <p:cNvPr id="3" name="text s10.1.0"/>
+          <p:cNvPr id="3" name="shape s10.1.0"/>
+          <p:cNvSpPr/>
+          <p:nvPr/>
+        </p:nvSpPr>
+        <p:spPr>
+          <a:xfrm>
+            <a:off x="609600" y="1478161"/>
+            <a:ext cx="5372100" cy="4770239"/>
+          </a:xfrm>
+          <a:prstGeom prst="roundRect">
+            <a:avLst>
+              <a:gd name="adj" fmla="val 4792"/>
+            </a:avLst>
+          </a:prstGeom>
+          <a:solidFill>
+            <a:schemeClr val="bg2"/>
+          </a:solidFill>
+          <a:ln>
+            <a:noFill/>
+          </a:ln>
+        </p:spPr>
+        <p:txBody>
+          <a:bodyPr wrap="square" lIns="342900" tIns="342900" rIns="342900" bIns="342900" anchor="t">
+            <a:normAutofit/>
+          </a:bodyPr>
+          <a:lstStyle/>
+          <a:p/>
+        </p:txBody>
+      </p:sp>
+      <p:sp>
+        <p:nvSpPr>
+          <p:cNvPr id="4" name="text s10.1.0.0.0"/>
           <p:cNvSpPr txBox="1"/>
           <p:nvPr/>
         </p:nvSpPr>
         <p:spPr>
           <a:xfrm>
-            <a:off x="609600" y="1478161"/>
-            <a:ext cx="5372100" cy="257175"/>
+            <a:off x="1019324" y="1887885"/>
+            <a:ext cx="4552652" cy="257175"/>
           </a:xfrm>
           <a:prstGeom prst="rect">
             <a:avLst/>
@@ -1597,14 +1628,14 @@
       </p:sp>
       <p:sp>
         <p:nvSpPr>
-          <p:cNvPr id="4" name="ul s10.1.1"/>
+          <p:cNvPr id="5" name="ul s10.1.0.0.1"/>
           <p:cNvSpPr txBox="1"/>
           <p:nvPr/>
         </p:nvSpPr>
         <p:spPr>
           <a:xfrm>
-            <a:off x="609600" y="1963936"/>
-            <a:ext cx="5372100" cy="1714500"/>
+            <a:off x="1019324" y="2373660"/>
+            <a:ext cx="4552652" cy="2571750"/>
           </a:xfrm>
           <a:prstGeom prst="rect">
             <a:avLst/>
@@ -1673,7 +1704,7 @@
                 <a:latin typeface="+mn-lt"/>
                 <a:ea typeface="+mn-ea"/>
               </a:rPr>
-              <a:t>슬라이드 레이아웃 11종과 슬롯 — 슬롯은 PPTX에서 진짜 플레이스홀더가 된다</a:t>
+              <a:t>레이아웃 11종과 슬롯 — 슬롯은 PPTX에서 진짜 플레이스홀더가 된다</a:t>
             </a:r>
           </a:p>
           <a:p>
@@ -1692,21 +1723,90 @@
                 <a:latin typeface="+mn-lt"/>
                 <a:ea typeface="+mn-ea"/>
               </a:rPr>
-              <a:t>테마 패키지 로딩 — 토큰 · 컴포넌트 · 배치 CSS가 파일이다</a:t>
-            </a:r>
-          </a:p>
-        </p:txBody>
-      </p:sp>
-      <p:sp>
-        <p:nvSpPr>
-          <p:cNvPr id="5" name="text s10.2.0"/>
+              <a:t>표와 차트 · 코드 강조 · 단계별 공개</a:t>
+            </a:r>
+          </a:p>
+          <a:p>
+            <a:pPr marL="342900" indent="-342900" algn="l">
+              <a:lnSpc>
+                <a:spcPts val="2250"/>
+              </a:lnSpc>
+              <a:buFont typeface="+mn-lt"/>
+              <a:buChar char="•"/>
+            </a:pPr>
+            <a:r>
+              <a:rPr sz="1500" b="0">
+                <a:solidFill>
+                  <a:schemeClr val="tx1"/>
+                </a:solidFill>
+                <a:latin typeface="+mn-lt"/>
+                <a:ea typeface="+mn-ea"/>
+              </a:rPr>
+              <a:t>내장 테마 셋과 외부 테마 패키지</a:t>
+            </a:r>
+          </a:p>
+          <a:p>
+            <a:pPr marL="342900" indent="-342900" algn="l">
+              <a:lnSpc>
+                <a:spcPts val="2250"/>
+              </a:lnSpc>
+              <a:buFont typeface="+mn-lt"/>
+              <a:buChar char="•"/>
+            </a:pPr>
+            <a:r>
+              <a:rPr sz="1500" b="0">
+                <a:solidFill>
+                  <a:schemeClr val="tx1"/>
+                </a:solidFill>
+                <a:latin typeface="+mn-lt"/>
+                <a:ea typeface="+mn-ea"/>
+              </a:rPr>
+              <a:t>init · build · check · watch · preview</a:t>
+            </a:r>
+          </a:p>
+        </p:txBody>
+      </p:sp>
+      <p:sp>
+        <p:nvSpPr>
+          <p:cNvPr id="6" name="shape s10.2.0"/>
+          <p:cNvSpPr/>
+          <p:nvPr/>
+        </p:nvSpPr>
+        <p:spPr>
+          <a:xfrm>
+            <a:off x="6210300" y="1478161"/>
+            <a:ext cx="5372100" cy="4770239"/>
+          </a:xfrm>
+          <a:prstGeom prst="roundRect">
+            <a:avLst>
+              <a:gd name="adj" fmla="val 4792"/>
+            </a:avLst>
+          </a:prstGeom>
+          <a:solidFill>
+            <a:schemeClr val="bg2"/>
+          </a:solidFill>
+          <a:ln>
+            <a:noFill/>
+          </a:ln>
+        </p:spPr>
+        <p:txBody>
+          <a:bodyPr wrap="square" lIns="342900" tIns="342900" rIns="342900" bIns="342900" anchor="t">
+            <a:normAutofit/>
+          </a:bodyPr>
+          <a:lstStyle/>
+          <a:p/>
+        </p:txBody>
+      </p:sp>
+      <p:sp>
+        <p:nvSpPr>
+          <p:cNvPr id="7" name="text s10.2.0.0.0"/>
           <p:cNvSpPr txBox="1"/>
           <p:nvPr/>
         </p:nvSpPr>
         <p:spPr>
           <a:xfrm>
-            <a:off x="6210300" y="1478161"/>
-            <a:ext cx="5372100" cy="257175"/>
+            <a:off x="6620024" y="1887885"/>
+            <a:ext cx="4552652" cy="257175"/>
           </a:xfrm>
           <a:prstGeom prst="rect">
             <a:avLst/>
@@ -1742,14 +1842,14 @@
       </p:sp>
       <p:sp>
         <p:nvSpPr>
-          <p:cNvPr id="6" name="ul s10.2.1"/>
+          <p:cNvPr id="8" name="ul s10.2.0.0.1"/>
           <p:cNvSpPr txBox="1"/>
           <p:nvPr/>
         </p:nvSpPr>
         <p:spPr>
           <a:xfrm>
-            <a:off x="6210300" y="1963936"/>
-            <a:ext cx="5372100" cy="1428750"/>
+            <a:off x="6620024" y="2373660"/>
+            <a:ext cx="4552652" cy="1143000"/>
           </a:xfrm>
           <a:prstGeom prst="rect">
             <a:avLst/>
@@ -1780,7 +1880,7 @@
                 <a:latin typeface="+mn-lt"/>
                 <a:ea typeface="+mn-ea"/>
               </a:rPr>
-              <a:t>표 렌더러와 차트 — 데이터를 담는 어휘 (표는 아직 문법까지만 있다)</a:t>
+              <a:t>테마가 소유하는 배경과 자산 — 배경 그림 · 로고</a:t>
             </a:r>
           </a:p>
           <a:p>
@@ -1799,7 +1899,7 @@
                 <a:latin typeface="+mn-lt"/>
                 <a:ea typeface="+mn-ea"/>
               </a:rPr>
-              <a:t>테마 여러 개와 색 팔레트 확장, 외부 테마 패키지</a:t>
+              <a:t>테마 variant의 그라디언트 토큰</a:t>
             </a:r>
           </a:p>
           <a:p>
@@ -1818,7 +1918,7 @@
                 <a:latin typeface="+mn-lt"/>
                 <a:ea typeface="+mn-ea"/>
               </a:rPr>
-              <a:t>합성 컴포넌트와 아이콘 — 반복 카드를 복사하지 않는다</a:t>
+              <a:t>측정 브라우저에 없는 테마 글꼴 경고</a:t>
             </a:r>
           </a:p>
           <a:p>
@@ -1837,7 +1937,7 @@
                 <a:latin typeface="+mn-lt"/>
                 <a:ea typeface="+mn-ea"/>
               </a:rPr>
-              <a:t>커넥터 · 그룹, 그리고 작성 도구 (init · server · check)</a:t>
+              <a:t>진단 다듬기 — 오타 후보 · 정렬 · 한 사고 한 경고</a:t>
             </a:r>
           </a:p>
         </p:txBody>
@@ -1875,8 +1975,8 @@
         </p:nvSpPr>
         <p:spPr>
           <a:xfrm>
-            <a:off x="609600" y="2364135"/>
-            <a:ext cx="10972800" cy="639961"/>
+            <a:off x="609600" y="2202210"/>
+            <a:ext cx="10972800" cy="914400"/>
           </a:xfrm>
           <a:prstGeom prst="rect">
             <a:avLst/>
@@ -1894,11 +1994,11 @@
           <a:p>
             <a:pPr algn="ctr">
               <a:lnSpc>
-                <a:spcPts val="5040"/>
-              </a:lnSpc>
-            </a:pPr>
-            <a:r>
-              <a:rPr sz="4200" b="1">
+                <a:spcPts val="7200"/>
+              </a:lnSpc>
+            </a:pPr>
+            <a:r>
+              <a:rPr sz="6000" b="1">
                 <a:solidFill>
                   <a:schemeClr val="tx1"/>
                 </a:solidFill>
@@ -1918,8 +2018,8 @@
         </p:nvSpPr>
         <p:spPr>
           <a:xfrm>
-            <a:off x="609600" y="3232696"/>
-            <a:ext cx="10972800" cy="346621"/>
+            <a:off x="609600" y="3345210"/>
+            <a:ext cx="10972800" cy="396180"/>
           </a:xfrm>
           <a:prstGeom prst="rect">
             <a:avLst/>
@@ -1937,11 +2037,11 @@
           <a:p>
             <a:pPr algn="ctr">
               <a:lnSpc>
-                <a:spcPts val="2730"/>
-              </a:lnSpc>
-            </a:pPr>
-            <a:r>
-              <a:rPr sz="2100" b="1">
+                <a:spcPts val="3120"/>
+              </a:lnSpc>
+            </a:pPr>
+            <a:r>
+              <a:rPr sz="2400" b="1">
                 <a:solidFill>
                   <a:schemeClr val="tx2"/>
                 </a:solidFill>
@@ -1955,14 +2055,14 @@
       </p:sp>
       <p:sp>
         <p:nvSpPr>
-          <p:cNvPr id="4" name="shape s11.2"/>
+          <p:cNvPr id="4" name="shape s11.2.0"/>
           <p:cNvSpPr/>
           <p:nvPr/>
         </p:nvSpPr>
         <p:spPr>
           <a:xfrm>
-            <a:off x="3048000" y="3807916"/>
-            <a:ext cx="6096000" cy="685800"/>
+            <a:off x="609600" y="3969990"/>
+            <a:ext cx="3505200" cy="685800"/>
           </a:xfrm>
           <a:prstGeom prst="roundRect">
             <a:avLst>
@@ -1998,7 +2098,107 @@
                 <a:latin typeface="Noto Sans Mono"/>
                 <a:ea typeface="Noto Sans Mono CJK KR"/>
               </a:rPr>
-              <a:t>balpyo build --target html,pptx</a:t>
+              <a:t>balpyo init my-talk</a:t>
+            </a:r>
+          </a:p>
+        </p:txBody>
+      </p:sp>
+      <p:sp>
+        <p:nvSpPr>
+          <p:cNvPr id="5" name="shape s11.2.1"/>
+          <p:cNvSpPr/>
+          <p:nvPr/>
+        </p:nvSpPr>
+        <p:spPr>
+          <a:xfrm>
+            <a:off x="4343400" y="3969990"/>
+            <a:ext cx="3505200" cy="685800"/>
+          </a:xfrm>
+          <a:prstGeom prst="roundRect">
+            <a:avLst>
+              <a:gd name="adj" fmla="val 33333"/>
+            </a:avLst>
+          </a:prstGeom>
+          <a:solidFill>
+            <a:schemeClr val="bg2"/>
+          </a:solidFill>
+          <a:ln w="9525">
+            <a:solidFill>
+              <a:schemeClr val="accent1"/>
+            </a:solidFill>
+            <a:prstDash val="solid"/>
+          </a:ln>
+        </p:spPr>
+        <p:txBody>
+          <a:bodyPr wrap="square" lIns="114300" tIns="114300" rIns="114300" bIns="114300" anchor="ctr">
+            <a:normAutofit/>
+          </a:bodyPr>
+          <a:lstStyle/>
+          <a:p>
+            <a:pPr algn="ctr">
+              <a:lnSpc>
+                <a:spcPts val="2250"/>
+              </a:lnSpc>
+            </a:pPr>
+            <a:r>
+              <a:rPr sz="1500" b="0">
+                <a:solidFill>
+                  <a:schemeClr val="tx1"/>
+                </a:solidFill>
+                <a:latin typeface="Noto Sans Mono"/>
+                <a:ea typeface="Noto Sans Mono CJK KR"/>
+              </a:rPr>
+              <a:t>balpyo build</a:t>
+            </a:r>
+          </a:p>
+        </p:txBody>
+      </p:sp>
+      <p:sp>
+        <p:nvSpPr>
+          <p:cNvPr id="6" name="shape s11.2.2"/>
+          <p:cNvSpPr/>
+          <p:nvPr/>
+        </p:nvSpPr>
+        <p:spPr>
+          <a:xfrm>
+            <a:off x="8077200" y="3969990"/>
+            <a:ext cx="3505200" cy="685800"/>
+          </a:xfrm>
+          <a:prstGeom prst="roundRect">
+            <a:avLst>
+              <a:gd name="adj" fmla="val 33333"/>
+            </a:avLst>
+          </a:prstGeom>
+          <a:solidFill>
+            <a:schemeClr val="bg2"/>
+          </a:solidFill>
+          <a:ln w="9525">
+            <a:solidFill>
+              <a:schemeClr val="accent1"/>
+            </a:solidFill>
+            <a:prstDash val="solid"/>
+          </a:ln>
+        </p:spPr>
+        <p:txBody>
+          <a:bodyPr wrap="square" lIns="114300" tIns="114300" rIns="114300" bIns="114300" anchor="ctr">
+            <a:normAutofit/>
+          </a:bodyPr>
+          <a:lstStyle/>
+          <a:p>
+            <a:pPr algn="ctr">
+              <a:lnSpc>
+                <a:spcPts val="2250"/>
+              </a:lnSpc>
+            </a:pPr>
+            <a:r>
+              <a:rPr sz="1500" b="0">
+                <a:solidFill>
+                  <a:schemeClr val="tx1"/>
+                </a:solidFill>
+                <a:latin typeface="Noto Sans Mono"/>
+                <a:ea typeface="Noto Sans Mono CJK KR"/>
+              </a:rPr>
+              <a:t>balpyo watch</a:t>
             </a:r>
           </a:p>
         </p:txBody>
@@ -2075,14 +2275,45 @@
       </p:sp>
       <p:sp>
         <p:nvSpPr>
-          <p:cNvPr id="3" name="text s1.1.0"/>
+          <p:cNvPr id="3" name="shape s1.1.0"/>
+          <p:cNvSpPr/>
+          <p:nvPr/>
+        </p:nvSpPr>
+        <p:spPr>
+          <a:xfrm>
+            <a:off x="609600" y="1478161"/>
+            <a:ext cx="5372100" cy="4770239"/>
+          </a:xfrm>
+          <a:prstGeom prst="roundRect">
+            <a:avLst>
+              <a:gd name="adj" fmla="val 4792"/>
+            </a:avLst>
+          </a:prstGeom>
+          <a:solidFill>
+            <a:schemeClr val="bg2"/>
+          </a:solidFill>
+          <a:ln>
+            <a:noFill/>
+          </a:ln>
+        </p:spPr>
+        <p:txBody>
+          <a:bodyPr wrap="square" lIns="342900" tIns="342900" rIns="342900" bIns="342900" anchor="t">
+            <a:normAutofit/>
+          </a:bodyPr>
+          <a:lstStyle/>
+          <a:p/>
+        </p:txBody>
+      </p:sp>
+      <p:sp>
+        <p:nvSpPr>
+          <p:cNvPr id="4" name="text s1.1.0.0.0.0"/>
           <p:cNvSpPr txBox="1"/>
           <p:nvPr/>
         </p:nvSpPr>
         <p:spPr>
           <a:xfrm>
-            <a:off x="609600" y="1478161"/>
-            <a:ext cx="5372100" cy="257175"/>
+            <a:off x="1019324" y="1887885"/>
+            <a:ext cx="4552652" cy="257175"/>
           </a:xfrm>
           <a:prstGeom prst="rect">
             <a:avLst/>
@@ -2118,14 +2349,14 @@
       </p:sp>
       <p:sp>
         <p:nvSpPr>
-          <p:cNvPr id="4" name="ul s1.1.1"/>
+          <p:cNvPr id="5" name="ul s1.1.0.0.0.1"/>
           <p:cNvSpPr txBox="1"/>
           <p:nvPr/>
         </p:nvSpPr>
         <p:spPr>
           <a:xfrm>
-            <a:off x="609600" y="1963936"/>
-            <a:ext cx="5372100" cy="1371600"/>
+            <a:off x="1019324" y="2373660"/>
+            <a:ext cx="4552652" cy="1371600"/>
           </a:xfrm>
           <a:prstGeom prst="rect">
             <a:avLst/>
@@ -2182,14 +2413,14 @@
       </p:sp>
       <p:sp>
         <p:nvSpPr>
-          <p:cNvPr id="5" name="text s1.1.2"/>
+          <p:cNvPr id="6" name="text s1.1.0.0.1"/>
           <p:cNvSpPr txBox="1"/>
           <p:nvPr/>
         </p:nvSpPr>
         <p:spPr>
           <a:xfrm>
-            <a:off x="609600" y="3564136"/>
-            <a:ext cx="5372100" cy="297061"/>
+            <a:off x="1019324" y="5492055"/>
+            <a:ext cx="4552652" cy="346621"/>
           </a:xfrm>
           <a:prstGeom prst="rect">
             <a:avLst/>
@@ -2207,11 +2438,11 @@
           <a:p>
             <a:pPr algn="l">
               <a:lnSpc>
-                <a:spcPts val="2340"/>
-              </a:lnSpc>
-            </a:pPr>
-            <a:r>
-              <a:rPr sz="1800" b="1">
+                <a:spcPts val="2730"/>
+              </a:lnSpc>
+            </a:pPr>
+            <a:r>
+              <a:rPr sz="2100" b="1">
                 <a:solidFill>
                   <a:schemeClr val="accent1"/>
                 </a:solidFill>
@@ -2225,14 +2456,45 @@
       </p:sp>
       <p:sp>
         <p:nvSpPr>
-          <p:cNvPr id="6" name="text s1.2.0"/>
+          <p:cNvPr id="7" name="shape s1.2.0"/>
+          <p:cNvSpPr/>
+          <p:nvPr/>
+        </p:nvSpPr>
+        <p:spPr>
+          <a:xfrm>
+            <a:off x="6210300" y="1478161"/>
+            <a:ext cx="5372100" cy="4770239"/>
+          </a:xfrm>
+          <a:prstGeom prst="roundRect">
+            <a:avLst>
+              <a:gd name="adj" fmla="val 4792"/>
+            </a:avLst>
+          </a:prstGeom>
+          <a:solidFill>
+            <a:schemeClr val="bg2"/>
+          </a:solidFill>
+          <a:ln>
+            <a:noFill/>
+          </a:ln>
+        </p:spPr>
+        <p:txBody>
+          <a:bodyPr wrap="square" lIns="342900" tIns="342900" rIns="342900" bIns="342900" anchor="t">
+            <a:normAutofit/>
+          </a:bodyPr>
+          <a:lstStyle/>
+          <a:p/>
+        </p:txBody>
+      </p:sp>
+      <p:sp>
+        <p:nvSpPr>
+          <p:cNvPr id="8" name="text s1.2.0.0.0.0"/>
           <p:cNvSpPr txBox="1"/>
           <p:nvPr/>
         </p:nvSpPr>
         <p:spPr>
           <a:xfrm>
-            <a:off x="6210300" y="1478161"/>
-            <a:ext cx="5372100" cy="257175"/>
+            <a:off x="6620024" y="1887885"/>
+            <a:ext cx="4552652" cy="257175"/>
           </a:xfrm>
           <a:prstGeom prst="rect">
             <a:avLst/>
@@ -2268,14 +2530,14 @@
       </p:sp>
       <p:sp>
         <p:nvSpPr>
-          <p:cNvPr id="7" name="ul s1.2.1"/>
+          <p:cNvPr id="9" name="ul s1.2.0.0.0.1"/>
           <p:cNvSpPr txBox="1"/>
           <p:nvPr/>
         </p:nvSpPr>
         <p:spPr>
           <a:xfrm>
-            <a:off x="6210300" y="1963936"/>
-            <a:ext cx="5372100" cy="1028700"/>
+            <a:off x="6620024" y="2373660"/>
+            <a:ext cx="4552652" cy="1028700"/>
           </a:xfrm>
           <a:prstGeom prst="rect">
             <a:avLst/>
@@ -2332,14 +2594,14 @@
       </p:sp>
       <p:sp>
         <p:nvSpPr>
-          <p:cNvPr id="8" name="text s1.2.2"/>
+          <p:cNvPr id="10" name="text s1.2.0.0.1"/>
           <p:cNvSpPr txBox="1"/>
           <p:nvPr/>
         </p:nvSpPr>
         <p:spPr>
           <a:xfrm>
-            <a:off x="6210300" y="3221236"/>
-            <a:ext cx="5372100" cy="297061"/>
+            <a:off x="6620024" y="5492055"/>
+            <a:ext cx="4552652" cy="346621"/>
           </a:xfrm>
           <a:prstGeom prst="rect">
             <a:avLst/>
@@ -2357,11 +2619,11 @@
           <a:p>
             <a:pPr algn="l">
               <a:lnSpc>
-                <a:spcPts val="2340"/>
-              </a:lnSpc>
-            </a:pPr>
-            <a:r>
-              <a:rPr sz="1800" b="1">
+                <a:spcPts val="2730"/>
+              </a:lnSpc>
+            </a:pPr>
+            <a:r>
+              <a:rPr sz="2100" b="1">
                 <a:solidFill>
                   <a:schemeClr val="accent1"/>
                 </a:solidFill>
@@ -2406,7 +2668,7 @@
         </p:nvSpPr>
         <p:spPr>
           <a:xfrm>
-            <a:off x="609600" y="1538288"/>
+            <a:off x="609600" y="609600"/>
             <a:ext cx="10972800" cy="239911"/>
           </a:xfrm>
           <a:prstGeom prst="rect">
@@ -2423,7 +2685,7 @@
           </a:bodyPr>
           <a:lstStyle/>
           <a:p>
-            <a:pPr algn="ctr">
+            <a:pPr algn="l">
               <a:lnSpc>
                 <a:spcPts val="1890"/>
               </a:lnSpc>
@@ -2443,14 +2705,45 @@
       </p:sp>
       <p:sp>
         <p:nvSpPr>
-          <p:cNvPr id="3" name="text s2.1"/>
+          <p:cNvPr id="3" name="shape s2.1.0"/>
+          <p:cNvSpPr/>
+          <p:nvPr/>
+        </p:nvSpPr>
+        <p:spPr>
+          <a:xfrm>
+            <a:off x="609600" y="1078111"/>
+            <a:ext cx="6377880" cy="5170289"/>
+          </a:xfrm>
+          <a:prstGeom prst="roundRect">
+            <a:avLst>
+              <a:gd name="adj" fmla="val 4421"/>
+            </a:avLst>
+          </a:prstGeom>
+          <a:solidFill>
+            <a:schemeClr val="bg2"/>
+          </a:solidFill>
+          <a:ln>
+            <a:noFill/>
+          </a:ln>
+        </p:spPr>
+        <p:txBody>
+          <a:bodyPr wrap="square" lIns="342900" tIns="342900" rIns="342900" bIns="342900" anchor="t">
+            <a:normAutofit/>
+          </a:bodyPr>
+          <a:lstStyle/>
+          <a:p/>
+        </p:txBody>
+      </p:sp>
+      <p:sp>
+        <p:nvSpPr>
+          <p:cNvPr id="4" name="text s2.1.0.0.0"/>
           <p:cNvSpPr txBox="1"/>
           <p:nvPr/>
         </p:nvSpPr>
         <p:spPr>
           <a:xfrm>
-            <a:off x="609600" y="2006798"/>
-            <a:ext cx="10972800" cy="2057400"/>
+            <a:off x="1019324" y="2205930"/>
+            <a:ext cx="5558433" cy="257175"/>
           </a:xfrm>
           <a:prstGeom prst="rect">
             <a:avLst/>
@@ -2466,7 +2759,50 @@
           </a:bodyPr>
           <a:lstStyle/>
           <a:p>
-            <a:pPr algn="ctr">
+            <a:pPr algn="l">
+              <a:lnSpc>
+                <a:spcPts val="2025"/>
+              </a:lnSpc>
+            </a:pPr>
+            <a:r>
+              <a:rPr sz="1350" b="1">
+                <a:solidFill>
+                  <a:schemeClr val="accent1"/>
+                </a:solidFill>
+                <a:latin typeface="+mn-lt"/>
+                <a:ea typeface="+mn-ea"/>
+              </a:rPr>
+              <a:t>python-pptx</a:t>
+            </a:r>
+          </a:p>
+        </p:txBody>
+      </p:sp>
+      <p:sp>
+        <p:nvSpPr>
+          <p:cNvPr id="5" name="text s2.1.0.0.1"/>
+          <p:cNvSpPr txBox="1"/>
+          <p:nvPr/>
+        </p:nvSpPr>
+        <p:spPr>
+          <a:xfrm>
+            <a:off x="1019324" y="2577405"/>
+            <a:ext cx="5558433" cy="2057400"/>
+          </a:xfrm>
+          <a:prstGeom prst="rect">
+            <a:avLst/>
+          </a:prstGeom>
+          <a:noFill/>
+          <a:ln>
+            <a:noFill/>
+          </a:ln>
+        </p:spPr>
+        <p:txBody>
+          <a:bodyPr wrap="square" lIns="0" tIns="0" rIns="0" bIns="0" anchor="t">
+            <a:normAutofit/>
+          </a:bodyPr>
+          <a:lstStyle/>
+          <a:p>
+            <a:pPr algn="l">
               <a:lnSpc>
                 <a:spcPts val="16200"/>
               </a:lnSpc>
@@ -2486,14 +2822,14 @@
       </p:sp>
       <p:sp>
         <p:nvSpPr>
-          <p:cNvPr id="4" name="text s2.2"/>
+          <p:cNvPr id="6" name="text s2.1.0.0.2"/>
           <p:cNvSpPr txBox="1"/>
           <p:nvPr/>
         </p:nvSpPr>
         <p:spPr>
           <a:xfrm>
-            <a:off x="609600" y="4292798"/>
-            <a:ext cx="10972800" cy="445740"/>
+            <a:off x="1019324" y="4749105"/>
+            <a:ext cx="5558433" cy="371475"/>
           </a:xfrm>
           <a:prstGeom prst="rect">
             <a:avLst/>
@@ -2509,13 +2845,13 @@
           </a:bodyPr>
           <a:lstStyle/>
           <a:p>
-            <a:pPr algn="ctr">
-              <a:lnSpc>
-                <a:spcPts val="3510"/>
-              </a:lnSpc>
-            </a:pPr>
-            <a:r>
-              <a:rPr sz="2700" b="1">
+            <a:pPr algn="l">
+              <a:lnSpc>
+                <a:spcPts val="2925"/>
+              </a:lnSpc>
+            </a:pPr>
+            <a:r>
+              <a:rPr sz="2250" b="1">
                 <a:solidFill>
                   <a:schemeClr val="tx1"/>
                 </a:solidFill>
@@ -2529,14 +2865,45 @@
       </p:sp>
       <p:sp>
         <p:nvSpPr>
-          <p:cNvPr id="5" name="text s2.3"/>
+          <p:cNvPr id="7" name="shape s2.1.1"/>
+          <p:cNvSpPr/>
+          <p:nvPr/>
+        </p:nvSpPr>
+        <p:spPr>
+          <a:xfrm>
+            <a:off x="7330380" y="1078111"/>
+            <a:ext cx="4251871" cy="5170289"/>
+          </a:xfrm>
+          <a:prstGeom prst="roundRect">
+            <a:avLst>
+              <a:gd name="adj" fmla="val 5376"/>
+            </a:avLst>
+          </a:prstGeom>
+          <a:solidFill>
+            <a:schemeClr val="accent1"/>
+          </a:solidFill>
+          <a:ln>
+            <a:noFill/>
+          </a:ln>
+        </p:spPr>
+        <p:txBody>
+          <a:bodyPr wrap="square" lIns="342900" tIns="342900" rIns="342900" bIns="342900" anchor="t">
+            <a:normAutofit/>
+          </a:bodyPr>
+          <a:lstStyle/>
+          <a:p/>
+        </p:txBody>
+      </p:sp>
+      <p:sp>
+        <p:nvSpPr>
+          <p:cNvPr id="8" name="text s2.1.1.0.0"/>
           <p:cNvSpPr txBox="1"/>
           <p:nvPr/>
         </p:nvSpPr>
         <p:spPr>
           <a:xfrm>
-            <a:off x="609600" y="4967139"/>
-            <a:ext cx="10972800" cy="352425"/>
+            <a:off x="7740104" y="2360265"/>
+            <a:ext cx="3432423" cy="257175"/>
           </a:xfrm>
           <a:prstGeom prst="rect">
             <a:avLst/>
@@ -2552,40 +2919,149 @@
           </a:bodyPr>
           <a:lstStyle/>
           <a:p>
-            <a:pPr algn="ctr">
-              <a:lnSpc>
-                <a:spcPts val="2700"/>
-              </a:lnSpc>
-            </a:pPr>
-            <a:r>
-              <a:rPr sz="1800" b="0">
-                <a:solidFill>
-                  <a:schemeClr val="tx2"/>
-                </a:solidFill>
-                <a:latin typeface="+mn-lt"/>
-                <a:ea typeface="+mn-ea"/>
-              </a:rPr>
-              <a:t>balpyo는 그 128회를 </a:t>
-            </a:r>
-            <a:r>
-              <a:rPr sz="1800" b="0" i="0" u="none">
-                <a:solidFill>
-                  <a:schemeClr val="tx2"/>
+            <a:pPr algn="l">
+              <a:lnSpc>
+                <a:spcPts val="2025"/>
+              </a:lnSpc>
+            </a:pPr>
+            <a:r>
+              <a:rPr sz="1350" b="1">
+                <a:solidFill>
+                  <a:schemeClr val="bg1"/>
+                </a:solidFill>
+                <a:latin typeface="+mn-lt"/>
+                <a:ea typeface="+mn-ea"/>
+              </a:rPr>
+              <a:t>balpyo</a:t>
+            </a:r>
+          </a:p>
+        </p:txBody>
+      </p:sp>
+      <p:sp>
+        <p:nvSpPr>
+          <p:cNvPr id="9" name="text s2.1.1.0.1"/>
+          <p:cNvSpPr txBox="1"/>
+          <p:nvPr/>
+        </p:nvSpPr>
+        <p:spPr>
+          <a:xfrm>
+            <a:off x="7740104" y="2846040"/>
+            <a:ext cx="3432423" cy="1005780"/>
+          </a:xfrm>
+          <a:prstGeom prst="rect">
+            <a:avLst/>
+          </a:prstGeom>
+          <a:noFill/>
+          <a:ln>
+            <a:noFill/>
+          </a:ln>
+        </p:spPr>
+        <p:txBody>
+          <a:bodyPr wrap="square" lIns="0" tIns="0" rIns="0" bIns="0" anchor="t">
+            <a:normAutofit/>
+          </a:bodyPr>
+          <a:lstStyle/>
+          <a:p>
+            <a:pPr algn="l">
+              <a:lnSpc>
+                <a:spcPts val="7920"/>
+              </a:lnSpc>
+            </a:pPr>
+            <a:r>
+              <a:rPr sz="6600" b="1">
+                <a:solidFill>
+                  <a:schemeClr val="bg1"/>
+                </a:solidFill>
+                <a:latin typeface="+mj-lt"/>
+                <a:ea typeface="+mj-ea"/>
+              </a:rPr>
+              <a:t>1줄</a:t>
+            </a:r>
+          </a:p>
+        </p:txBody>
+      </p:sp>
+      <p:sp>
+        <p:nvSpPr>
+          <p:cNvPr id="10" name="text s2.1.1.0.2"/>
+          <p:cNvSpPr txBox="1"/>
+          <p:nvPr/>
+        </p:nvSpPr>
+        <p:spPr>
+          <a:xfrm>
+            <a:off x="7740104" y="4080421"/>
+            <a:ext cx="3432423" cy="314325"/>
+          </a:xfrm>
+          <a:prstGeom prst="rect">
+            <a:avLst/>
+          </a:prstGeom>
+          <a:noFill/>
+          <a:ln>
+            <a:noFill/>
+          </a:ln>
+        </p:spPr>
+        <p:txBody>
+          <a:bodyPr wrap="square" lIns="0" tIns="0" rIns="0" bIns="0" anchor="t">
+            <a:normAutofit/>
+          </a:bodyPr>
+          <a:lstStyle/>
+          <a:p>
+            <a:pPr algn="l">
+              <a:lnSpc>
+                <a:spcPts val="2475"/>
+              </a:lnSpc>
+            </a:pPr>
+            <a:r>
+              <a:rPr sz="1650" b="0">
+                <a:solidFill>
+                  <a:schemeClr val="bg1"/>
                 </a:solidFill>
                 <a:latin typeface="Noto Sans Mono"/>
                 <a:ea typeface="Noto Sans Mono CJK KR"/>
               </a:rPr>
               <a:t>&lt;grid cols="4"&gt;</a:t>
             </a:r>
+          </a:p>
+        </p:txBody>
+      </p:sp>
+      <p:sp>
+        <p:nvSpPr>
+          <p:cNvPr id="11" name="text s2.1.1.0.3"/>
+          <p:cNvSpPr txBox="1"/>
+          <p:nvPr/>
+        </p:nvSpPr>
+        <p:spPr>
+          <a:xfrm>
+            <a:off x="7740104" y="4623346"/>
+            <a:ext cx="3432423" cy="342900"/>
+          </a:xfrm>
+          <a:prstGeom prst="rect">
+            <a:avLst/>
+          </a:prstGeom>
+          <a:noFill/>
+          <a:ln>
+            <a:noFill/>
+          </a:ln>
+        </p:spPr>
+        <p:txBody>
+          <a:bodyPr wrap="square" lIns="0" tIns="0" rIns="0" bIns="0" anchor="t">
+            <a:normAutofit/>
+          </a:bodyPr>
+          <a:lstStyle/>
+          <a:p>
+            <a:pPr algn="l">
+              <a:lnSpc>
+                <a:spcPts val="2700"/>
+              </a:lnSpc>
+            </a:pPr>
             <a:r>
               <a:rPr sz="1800" b="0">
                 <a:solidFill>
-                  <a:schemeClr val="tx2"/>
-                </a:solidFill>
-                <a:latin typeface="+mn-lt"/>
-                <a:ea typeface="+mn-ea"/>
-              </a:rPr>
-              <a:t> 한 줄로 대체한다.</a:t>
+                  <a:schemeClr val="bg1"/>
+                </a:solidFill>
+                <a:latin typeface="+mn-lt"/>
+                <a:ea typeface="+mn-ea"/>
+              </a:rPr>
+              <a:t>좌표는 브라우저가 잰다.</a:t>
             </a:r>
           </a:p>
         </p:txBody>
@@ -2701,7 +3177,7 @@
         <p:spPr>
           <a:xfrm>
             <a:off x="609600" y="2278261"/>
-            <a:ext cx="2657475" cy="257175"/>
+            <a:ext cx="2657475" cy="285750"/>
           </a:xfrm>
           <a:prstGeom prst="rect">
             <a:avLst/>
@@ -2719,11 +3195,11 @@
           <a:p>
             <a:pPr algn="ctr">
               <a:lnSpc>
-                <a:spcPts val="2025"/>
-              </a:lnSpc>
-            </a:pPr>
-            <a:r>
-              <a:rPr sz="1350" b="0">
+                <a:spcPts val="2250"/>
+              </a:lnSpc>
+            </a:pPr>
+            <a:r>
+              <a:rPr sz="1500" b="0">
                 <a:solidFill>
                   <a:schemeClr val="tx1"/>
                 </a:solidFill>
@@ -2778,7 +3254,7 @@
         <p:spPr>
           <a:xfrm>
             <a:off x="3381375" y="2278261"/>
-            <a:ext cx="2657475" cy="257175"/>
+            <a:ext cx="2657475" cy="285750"/>
           </a:xfrm>
           <a:prstGeom prst="rect">
             <a:avLst/>
@@ -2796,11 +3272,11 @@
           <a:p>
             <a:pPr algn="ctr">
               <a:lnSpc>
-                <a:spcPts val="2025"/>
-              </a:lnSpc>
-            </a:pPr>
-            <a:r>
-              <a:rPr sz="1350" b="0">
+                <a:spcPts val="2250"/>
+              </a:lnSpc>
+            </a:pPr>
+            <a:r>
+              <a:rPr sz="1500" b="0">
                 <a:solidFill>
                   <a:schemeClr val="tx1"/>
                 </a:solidFill>
@@ -2855,7 +3331,7 @@
         <p:spPr>
           <a:xfrm>
             <a:off x="6153150" y="2278261"/>
-            <a:ext cx="2657475" cy="257175"/>
+            <a:ext cx="2657475" cy="285750"/>
           </a:xfrm>
           <a:prstGeom prst="rect">
             <a:avLst/>
@@ -2873,11 +3349,11 @@
           <a:p>
             <a:pPr algn="ctr">
               <a:lnSpc>
-                <a:spcPts val="2025"/>
-              </a:lnSpc>
-            </a:pPr>
-            <a:r>
-              <a:rPr sz="1350" b="0">
+                <a:spcPts val="2250"/>
+              </a:lnSpc>
+            </a:pPr>
+            <a:r>
+              <a:rPr sz="1500" b="0">
                 <a:solidFill>
                   <a:schemeClr val="tx1"/>
                 </a:solidFill>
@@ -2932,7 +3408,7 @@
         <p:spPr>
           <a:xfrm>
             <a:off x="8924925" y="2278261"/>
-            <a:ext cx="2657475" cy="257175"/>
+            <a:ext cx="2657475" cy="285750"/>
           </a:xfrm>
           <a:prstGeom prst="rect">
             <a:avLst/>
@@ -2950,11 +3426,11 @@
           <a:p>
             <a:pPr algn="ctr">
               <a:lnSpc>
-                <a:spcPts val="2025"/>
-              </a:lnSpc>
-            </a:pPr>
-            <a:r>
-              <a:rPr sz="1350" b="0">
+                <a:spcPts val="2250"/>
+              </a:lnSpc>
+            </a:pPr>
+            <a:r>
+              <a:rPr sz="1500" b="1" i="0" u="none">
                 <a:solidFill>
                   <a:schemeClr val="accent1"/>
                 </a:solidFill>
@@ -2974,12 +3450,12 @@
         </p:nvSpPr>
         <p:spPr>
           <a:xfrm>
-            <a:off x="609600" y="2764036"/>
-            <a:ext cx="5314950" cy="1905000"/>
+            <a:off x="609600" y="2792611"/>
+            <a:ext cx="5314950" cy="2987278"/>
           </a:xfrm>
           <a:prstGeom prst="roundRect">
             <a:avLst>
-              <a:gd name="adj" fmla="val 12000"/>
+              <a:gd name="adj" fmla="val 7652"/>
             </a:avLst>
           </a:prstGeom>
           <a:solidFill>
@@ -2997,56 +3473,149 @@
             <a:normAutofit/>
           </a:bodyPr>
           <a:lstStyle/>
+          <a:p/>
+        </p:txBody>
+      </p:sp>
+      <p:sp>
+        <p:nvSpPr>
+          <p:cNvPr id="12" name="text s3.2.0.0.0"/>
+          <p:cNvSpPr txBox="1"/>
+          <p:nvPr/>
+        </p:nvSpPr>
+        <p:spPr>
+          <a:xfrm>
+            <a:off x="1019324" y="3202335"/>
+            <a:ext cx="4495502" cy="371475"/>
+          </a:xfrm>
+          <a:prstGeom prst="rect">
+            <a:avLst/>
+          </a:prstGeom>
+          <a:noFill/>
+          <a:ln>
+            <a:noFill/>
+          </a:ln>
+        </p:spPr>
+        <p:txBody>
+          <a:bodyPr wrap="square" lIns="0" tIns="0" rIns="0" bIns="0" anchor="t">
+            <a:normAutofit/>
+          </a:bodyPr>
+          <a:lstStyle/>
           <a:p>
             <a:pPr algn="l">
               <a:lnSpc>
-                <a:spcPts val="2730"/>
-              </a:lnSpc>
-            </a:pPr>
-            <a:r>
-              <a:rPr sz="2100" b="1">
+                <a:spcPts val="2925"/>
+              </a:lnSpc>
+            </a:pPr>
+            <a:r>
+              <a:rPr sz="2250" b="1">
                 <a:solidFill>
                   <a:schemeClr val="accent1"/>
                 </a:solidFill>
                 <a:latin typeface="+mj-lt"/>
                 <a:ea typeface="+mj-ea"/>
               </a:rPr>
-              <a:t>웹</a:t>
-            </a:r>
-          </a:p>
-          <a:p>
-            <a:pPr algn="l">
-              <a:lnSpc>
-                <a:spcPts val="2250"/>
-              </a:lnSpc>
-            </a:pPr>
-            <a:r>
-              <a:rPr sz="1500" b="0">
+              <a:t>웹 · index.html 한 장</a:t>
+            </a:r>
+          </a:p>
+        </p:txBody>
+      </p:sp>
+      <p:sp>
+        <p:nvSpPr>
+          <p:cNvPr id="13" name="ul s3.2.0.0.1"/>
+          <p:cNvSpPr txBox="1"/>
+          <p:nvPr/>
+        </p:nvSpPr>
+        <p:spPr>
+          <a:xfrm>
+            <a:off x="1019324" y="3688110"/>
+            <a:ext cx="4495502" cy="1257300"/>
+          </a:xfrm>
+          <a:prstGeom prst="rect">
+            <a:avLst/>
+          </a:prstGeom>
+          <a:noFill/>
+          <a:ln>
+            <a:noFill/>
+          </a:ln>
+        </p:spPr>
+        <p:txBody>
+          <a:bodyPr wrap="square" lIns="0" tIns="0" rIns="0" bIns="0" anchor="t">
+            <a:normAutofit/>
+          </a:bodyPr>
+          <a:lstStyle/>
+          <a:p>
+            <a:pPr marL="342900" indent="-342900" algn="l">
+              <a:lnSpc>
+                <a:spcPts val="2475"/>
+              </a:lnSpc>
+              <a:buFont typeface="+mn-lt"/>
+              <a:buChar char="•"/>
+            </a:pPr>
+            <a:r>
+              <a:rPr sz="1650" b="0">
                 <a:solidFill>
                   <a:schemeClr val="tx1"/>
                 </a:solidFill>
                 <a:latin typeface="+mn-lt"/>
                 <a:ea typeface="+mn-ea"/>
               </a:rPr>
-              <a:t>HTML 한 장 + 인라인 발표 런타임. 확정된 외관은 요소의 style 선언으로, 색과 폰트는 테마 CSS 변수 참조로 나간다.</a:t>
-            </a:r>
-          </a:p>
-        </p:txBody>
-      </p:sp>
-      <p:sp>
-        <p:nvSpPr>
-          <p:cNvPr id="12" name="shape s3.2.1"/>
+              <a:t>CSS와 발표 런타임이 인라인 — 파일 하나로 배포한다</a:t>
+            </a:r>
+          </a:p>
+          <a:p>
+            <a:pPr marL="342900" indent="-342900" algn="l">
+              <a:lnSpc>
+                <a:spcPts val="2475"/>
+              </a:lnSpc>
+              <a:buFont typeface="+mn-lt"/>
+              <a:buChar char="•"/>
+            </a:pPr>
+            <a:r>
+              <a:rPr sz="1650" b="0">
+                <a:solidFill>
+                  <a:schemeClr val="tx1"/>
+                </a:solidFill>
+                <a:latin typeface="+mn-lt"/>
+                <a:ea typeface="+mn-ea"/>
+              </a:rPr>
+              <a:t>발표자 화면 · 개요 그리드 · 노트 · 장 링크</a:t>
+            </a:r>
+          </a:p>
+          <a:p>
+            <a:pPr marL="342900" indent="-342900" algn="l">
+              <a:lnSpc>
+                <a:spcPts val="2475"/>
+              </a:lnSpc>
+              <a:buFont typeface="+mn-lt"/>
+              <a:buChar char="•"/>
+            </a:pPr>
+            <a:r>
+              <a:rPr sz="1650" b="0">
+                <a:solidFill>
+                  <a:schemeClr val="tx1"/>
+                </a:solidFill>
+                <a:latin typeface="+mn-lt"/>
+                <a:ea typeface="+mn-ea"/>
+              </a:rPr>
+              <a:t>브라우저 인쇄가 곧 PDF다</a:t>
+            </a:r>
+          </a:p>
+        </p:txBody>
+      </p:sp>
+      <p:sp>
+        <p:nvSpPr>
+          <p:cNvPr id="14" name="shape s3.2.1"/>
           <p:cNvSpPr/>
           <p:nvPr/>
         </p:nvSpPr>
         <p:spPr>
           <a:xfrm>
-            <a:off x="6267450" y="2764036"/>
-            <a:ext cx="5314950" cy="1905000"/>
+            <a:off x="6267450" y="2792611"/>
+            <a:ext cx="5314950" cy="2987278"/>
           </a:xfrm>
           <a:prstGeom prst="roundRect">
             <a:avLst>
-              <a:gd name="adj" fmla="val 12000"/>
+              <a:gd name="adj" fmla="val 7652"/>
             </a:avLst>
           </a:prstGeom>
           <a:solidFill>
@@ -3064,51 +3633,144 @@
             <a:normAutofit/>
           </a:bodyPr>
           <a:lstStyle/>
+          <a:p/>
+        </p:txBody>
+      </p:sp>
+      <p:sp>
+        <p:nvSpPr>
+          <p:cNvPr id="15" name="text s3.2.1.0.0"/>
+          <p:cNvSpPr txBox="1"/>
+          <p:nvPr/>
+        </p:nvSpPr>
+        <p:spPr>
+          <a:xfrm>
+            <a:off x="6677174" y="3202335"/>
+            <a:ext cx="4495502" cy="371475"/>
+          </a:xfrm>
+          <a:prstGeom prst="rect">
+            <a:avLst/>
+          </a:prstGeom>
+          <a:noFill/>
+          <a:ln>
+            <a:noFill/>
+          </a:ln>
+        </p:spPr>
+        <p:txBody>
+          <a:bodyPr wrap="square" lIns="0" tIns="0" rIns="0" bIns="0" anchor="t">
+            <a:normAutofit/>
+          </a:bodyPr>
+          <a:lstStyle/>
           <a:p>
             <a:pPr algn="l">
               <a:lnSpc>
-                <a:spcPts val="2730"/>
-              </a:lnSpc>
-            </a:pPr>
-            <a:r>
-              <a:rPr sz="2100" b="1">
+                <a:spcPts val="2925"/>
+              </a:lnSpc>
+            </a:pPr>
+            <a:r>
+              <a:rPr sz="2250" b="1">
                 <a:solidFill>
                   <a:schemeClr val="accent1"/>
                 </a:solidFill>
                 <a:latin typeface="+mj-lt"/>
                 <a:ea typeface="+mj-ea"/>
               </a:rPr>
-              <a:t>PPTX</a:t>
-            </a:r>
-          </a:p>
-          <a:p>
-            <a:pPr algn="l">
-              <a:lnSpc>
-                <a:spcPts val="2250"/>
-              </a:lnSpc>
-            </a:pPr>
-            <a:r>
-              <a:rPr sz="1500" b="0">
+              <a:t>PPTX · 편집 가능한 원본</a:t>
+            </a:r>
+          </a:p>
+        </p:txBody>
+      </p:sp>
+      <p:sp>
+        <p:nvSpPr>
+          <p:cNvPr id="16" name="ul s3.2.1.0.1"/>
+          <p:cNvSpPr txBox="1"/>
+          <p:nvPr/>
+        </p:nvSpPr>
+        <p:spPr>
+          <a:xfrm>
+            <a:off x="6677174" y="3688110"/>
+            <a:ext cx="4495502" cy="1257300"/>
+          </a:xfrm>
+          <a:prstGeom prst="rect">
+            <a:avLst/>
+          </a:prstGeom>
+          <a:noFill/>
+          <a:ln>
+            <a:noFill/>
+          </a:ln>
+        </p:spPr>
+        <p:txBody>
+          <a:bodyPr wrap="square" lIns="0" tIns="0" rIns="0" bIns="0" anchor="t">
+            <a:normAutofit/>
+          </a:bodyPr>
+          <a:lstStyle/>
+          <a:p>
+            <a:pPr marL="342900" indent="-342900" algn="l">
+              <a:lnSpc>
+                <a:spcPts val="2475"/>
+              </a:lnSpc>
+              <a:buFont typeface="+mn-lt"/>
+              <a:buChar char="•"/>
+            </a:pPr>
+            <a:r>
+              <a:rPr sz="1650" b="0">
                 <a:solidFill>
                   <a:schemeClr val="tx1"/>
                 </a:solidFill>
                 <a:latin typeface="+mn-lt"/>
                 <a:ea typeface="+mn-ea"/>
               </a:rPr>
-              <a:t>네이티브 OOXML. 텍스트 박스는 p:sp, 도형은 prstGeom, 슬롯은 p:ph다 — 슬라이드를 이미지로 찍지 않는다.</a:t>
-            </a:r>
-          </a:p>
-        </p:txBody>
-      </p:sp>
-      <p:sp>
-        <p:nvSpPr>
-          <p:cNvPr id="13" name="text s3.3"/>
+              <a:t>텍스트 박스는 p:sp, 도형은 prstGeom, 표는 a:tbl</a:t>
+            </a:r>
+          </a:p>
+          <a:p>
+            <a:pPr marL="342900" indent="-342900" algn="l">
+              <a:lnSpc>
+                <a:spcPts val="2475"/>
+              </a:lnSpc>
+              <a:buFont typeface="+mn-lt"/>
+              <a:buChar char="•"/>
+            </a:pPr>
+            <a:r>
+              <a:rPr sz="1650" b="0">
+                <a:solidFill>
+                  <a:schemeClr val="tx1"/>
+                </a:solidFill>
+                <a:latin typeface="+mn-lt"/>
+                <a:ea typeface="+mn-ea"/>
+              </a:rPr>
+              <a:t>슬롯은 p:ph 플레이스홀더 — 레이아웃이 살아 있다</a:t>
+            </a:r>
+          </a:p>
+          <a:p>
+            <a:pPr marL="342900" indent="-342900" algn="l">
+              <a:lnSpc>
+                <a:spcPts val="2475"/>
+              </a:lnSpc>
+              <a:buFont typeface="+mn-lt"/>
+              <a:buChar char="•"/>
+            </a:pPr>
+            <a:r>
+              <a:rPr sz="1650" b="0">
+                <a:solidFill>
+                  <a:schemeClr val="tx1"/>
+                </a:solidFill>
+                <a:latin typeface="+mn-lt"/>
+                <a:ea typeface="+mn-ea"/>
+              </a:rPr>
+              <a:t>테마 색은 schemeClr — 이미지로 찍지 않는다</a:t>
+            </a:r>
+          </a:p>
+        </p:txBody>
+      </p:sp>
+      <p:sp>
+        <p:nvSpPr>
+          <p:cNvPr id="17" name="text s3.3"/>
           <p:cNvSpPr txBox="1"/>
           <p:nvPr/>
         </p:nvSpPr>
         <p:spPr>
           <a:xfrm>
-            <a:off x="609600" y="4897636"/>
+            <a:off x="609600" y="6008489"/>
             <a:ext cx="10972800" cy="239911"/>
           </a:xfrm>
           <a:prstGeom prst="rect">
@@ -3213,14 +3875,160 @@
       </p:sp>
       <p:sp>
         <p:nvSpPr>
-          <p:cNvPr id="3" name="pre s4.1.0"/>
+          <p:cNvPr id="3" name="shape s4.1.0"/>
+          <p:cNvSpPr/>
+          <p:nvPr/>
+        </p:nvSpPr>
+        <p:spPr>
+          <a:xfrm>
+            <a:off x="609600" y="1478161"/>
+            <a:ext cx="5257800" cy="3732014"/>
+          </a:xfrm>
+          <a:prstGeom prst="roundRect">
+            <a:avLst>
+              <a:gd name="adj" fmla="val 6125"/>
+            </a:avLst>
+          </a:prstGeom>
+          <a:solidFill>
+            <a:schemeClr val="bg2"/>
+          </a:solidFill>
+          <a:ln>
+            <a:noFill/>
+          </a:ln>
+        </p:spPr>
+        <p:txBody>
+          <a:bodyPr wrap="square" lIns="342900" tIns="342900" rIns="342900" bIns="342900" anchor="t">
+            <a:normAutofit/>
+          </a:bodyPr>
+          <a:lstStyle/>
+          <a:p>
+            <a:pPr algn="l">
+              <a:lnSpc>
+                <a:spcPts val="2025"/>
+              </a:lnSpc>
+            </a:pPr>
+            <a:r>
+              <a:rPr sz="1350" b="0">
+                <a:solidFill>
+                  <a:schemeClr val="tx1"/>
+                </a:solidFill>
+                <a:latin typeface="Noto Sans Mono"/>
+                <a:ea typeface="Noto Sans Mono CJK KR"/>
+              </a:rPr>
+              <a:t>my-deck/</a:t>
+            </a:r>
+            <a:br/>
+            <a:r>
+              <a:rPr sz="1350" b="0">
+                <a:solidFill>
+                  <a:schemeClr val="tx1"/>
+                </a:solidFill>
+                <a:latin typeface="Noto Sans Mono"/>
+                <a:ea typeface="Noto Sans Mono CJK KR"/>
+              </a:rPr>
+              <a:t>  balpyo.json</a:t>
+            </a:r>
+            <a:br/>
+            <a:r>
+              <a:rPr sz="1350" b="0">
+                <a:solidFill>
+                  <a:schemeClr val="tx1"/>
+                </a:solidFill>
+                <a:latin typeface="Noto Sans Mono"/>
+                <a:ea typeface="Noto Sans Mono CJK KR"/>
+              </a:rPr>
+              <a:t>  slides/</a:t>
+            </a:r>
+            <a:br/>
+            <a:r>
+              <a:rPr sz="1350" b="0">
+                <a:solidFill>
+                  <a:schemeClr val="tx1"/>
+                </a:solidFill>
+                <a:latin typeface="Noto Sans Mono"/>
+                <a:ea typeface="Noto Sans Mono CJK KR"/>
+              </a:rPr>
+              <a:t>    001_cover.slide</a:t>
+            </a:r>
+            <a:br/>
+            <a:r>
+              <a:rPr sz="1350" b="0">
+                <a:solidFill>
+                  <a:schemeClr val="tx1"/>
+                </a:solidFill>
+                <a:latin typeface="Noto Sans Mono"/>
+                <a:ea typeface="Noto Sans Mono CJK KR"/>
+              </a:rPr>
+              <a:t>    002_problem.slide</a:t>
+            </a:r>
+            <a:br/>
+            <a:r>
+              <a:rPr sz="1350" b="0">
+                <a:solidFill>
+                  <a:schemeClr val="tx1"/>
+                </a:solidFill>
+                <a:latin typeface="Noto Sans Mono"/>
+                <a:ea typeface="Noto Sans Mono CJK KR"/>
+              </a:rPr>
+              <a:t>    _draft_ideas.slide</a:t>
+            </a:r>
+            <a:br/>
+            <a:r>
+              <a:rPr sz="1350" b="0">
+                <a:solidFill>
+                  <a:schemeClr val="tx1"/>
+                </a:solidFill>
+                <a:latin typeface="Noto Sans Mono"/>
+                <a:ea typeface="Noto Sans Mono CJK KR"/>
+              </a:rPr>
+              <a:t>  assets/</a:t>
+            </a:r>
+            <a:br/>
+            <a:r>
+              <a:rPr sz="1350" b="0">
+                <a:solidFill>
+                  <a:schemeClr val="tx1"/>
+                </a:solidFill>
+                <a:latin typeface="Noto Sans Mono"/>
+                <a:ea typeface="Noto Sans Mono CJK KR"/>
+              </a:rPr>
+              <a:t>    diagram.png</a:t>
+            </a:r>
+            <a:br/>
+            <a:r>
+              <a:rPr sz="1350" b="0">
+                <a:solidFill>
+                  <a:schemeClr val="tx1"/>
+                </a:solidFill>
+                <a:latin typeface="Noto Sans Mono"/>
+                <a:ea typeface="Noto Sans Mono CJK KR"/>
+              </a:rPr>
+              <a:t>  themes/</a:t>
+            </a:r>
+            <a:br/>
+            <a:r>
+              <a:rPr sz="1350" b="0">
+                <a:solidFill>
+                  <a:schemeClr val="tx1"/>
+                </a:solidFill>
+                <a:latin typeface="Noto Sans Mono"/>
+                <a:ea typeface="Noto Sans Mono CJK KR"/>
+              </a:rPr>
+              <a:t>    my-brand/</a:t>
+            </a:r>
+          </a:p>
+        </p:txBody>
+      </p:sp>
+      <p:sp>
+        <p:nvSpPr>
+          <p:cNvPr id="4" name="text s4.1.1.0.0"/>
           <p:cNvSpPr txBox="1"/>
           <p:nvPr/>
         </p:nvSpPr>
         <p:spPr>
           <a:xfrm>
-            <a:off x="609600" y="1478161"/>
-            <a:ext cx="5257800" cy="2314575"/>
+            <a:off x="6324600" y="1478161"/>
+            <a:ext cx="5257800" cy="257175"/>
           </a:xfrm>
           <a:prstGeom prst="rect">
             <a:avLst/>
@@ -3231,8 +4039,8 @@
           </a:ln>
         </p:spPr>
         <p:txBody>
-          <a:bodyPr wrap="none" lIns="0" tIns="0" rIns="0" bIns="0" anchor="t">
-            <a:noAutofit/>
+          <a:bodyPr wrap="square" lIns="0" tIns="0" rIns="0" bIns="0" anchor="t">
+            <a:normAutofit/>
           </a:bodyPr>
           <a:lstStyle/>
           <a:p>
@@ -3242,116 +4050,28 @@
               </a:lnSpc>
             </a:pPr>
             <a:r>
-              <a:rPr sz="1350" b="0">
-                <a:solidFill>
-                  <a:schemeClr val="tx1"/>
-                </a:solidFill>
-                <a:latin typeface="Noto Sans Mono"/>
-                <a:ea typeface="Noto Sans Mono CJK KR"/>
-              </a:rPr>
-              <a:t>my-deck/</a:t>
-            </a:r>
-            <a:br/>
-            <a:r>
-              <a:rPr sz="1350" b="0">
-                <a:solidFill>
-                  <a:schemeClr val="tx1"/>
-                </a:solidFill>
-                <a:latin typeface="Noto Sans Mono"/>
-                <a:ea typeface="Noto Sans Mono CJK KR"/>
-              </a:rPr>
-              <a:t>  balpyo.json</a:t>
-            </a:r>
-            <a:br/>
-            <a:r>
-              <a:rPr sz="1350" b="0">
-                <a:solidFill>
-                  <a:schemeClr val="tx1"/>
-                </a:solidFill>
-                <a:latin typeface="Noto Sans Mono"/>
-                <a:ea typeface="Noto Sans Mono CJK KR"/>
-              </a:rPr>
-              <a:t>  slides/</a:t>
-            </a:r>
-            <a:br/>
-            <a:r>
-              <a:rPr sz="1350" b="0">
-                <a:solidFill>
-                  <a:schemeClr val="tx1"/>
-                </a:solidFill>
-                <a:latin typeface="Noto Sans Mono"/>
-                <a:ea typeface="Noto Sans Mono CJK KR"/>
-              </a:rPr>
-              <a:t>    001_cover.slide</a:t>
-            </a:r>
-            <a:br/>
-            <a:r>
-              <a:rPr sz="1350" b="0">
-                <a:solidFill>
-                  <a:schemeClr val="tx1"/>
-                </a:solidFill>
-                <a:latin typeface="Noto Sans Mono"/>
-                <a:ea typeface="Noto Sans Mono CJK KR"/>
-              </a:rPr>
-              <a:t>    002_problem.slide</a:t>
-            </a:r>
-            <a:br/>
-            <a:r>
-              <a:rPr sz="1350" b="0">
-                <a:solidFill>
-                  <a:schemeClr val="tx1"/>
-                </a:solidFill>
-                <a:latin typeface="Noto Sans Mono"/>
-                <a:ea typeface="Noto Sans Mono CJK KR"/>
-              </a:rPr>
-              <a:t>    _draft_ideas.slide</a:t>
-            </a:r>
-            <a:br/>
-            <a:r>
-              <a:rPr sz="1350" b="0">
-                <a:solidFill>
-                  <a:schemeClr val="tx1"/>
-                </a:solidFill>
-                <a:latin typeface="Noto Sans Mono"/>
-                <a:ea typeface="Noto Sans Mono CJK KR"/>
-              </a:rPr>
-              <a:t>  dist/</a:t>
-            </a:r>
-            <a:br/>
-            <a:r>
-              <a:rPr sz="1350" b="0">
-                <a:solidFill>
-                  <a:schemeClr val="tx1"/>
-                </a:solidFill>
-                <a:latin typeface="Noto Sans Mono"/>
-                <a:ea typeface="Noto Sans Mono CJK KR"/>
-              </a:rPr>
-              <a:t>    index.html</a:t>
-            </a:r>
-            <a:br/>
-            <a:r>
-              <a:rPr sz="1350" b="0">
-                <a:solidFill>
-                  <a:schemeClr val="tx1"/>
-                </a:solidFill>
-                <a:latin typeface="Noto Sans Mono"/>
-                <a:ea typeface="Noto Sans Mono CJK KR"/>
-              </a:rPr>
-              <a:t>    my-deck.pptx</a:t>
-            </a:r>
-          </a:p>
-        </p:txBody>
-      </p:sp>
-      <p:sp>
-        <p:nvSpPr>
-          <p:cNvPr id="4" name="text s4.1.1.0"/>
+              <a:rPr sz="1350" b="1">
+                <a:solidFill>
+                  <a:schemeClr val="accent1"/>
+                </a:solidFill>
+                <a:latin typeface="+mn-lt"/>
+                <a:ea typeface="+mn-ea"/>
+              </a:rPr>
+              <a:t>수집 규칙</a:t>
+            </a:r>
+          </a:p>
+        </p:txBody>
+      </p:sp>
+      <p:sp>
+        <p:nvSpPr>
+          <p:cNvPr id="5" name="ul s4.1.1.0.1"/>
           <p:cNvSpPr txBox="1"/>
           <p:nvPr/>
         </p:nvSpPr>
         <p:spPr>
           <a:xfrm>
-            <a:off x="6324600" y="1478161"/>
-            <a:ext cx="5257800" cy="257175"/>
+            <a:off x="6324600" y="1849636"/>
+            <a:ext cx="5257800" cy="1371600"/>
           </a:xfrm>
           <a:prstGeom prst="rect">
             <a:avLst/>
@@ -3367,34 +4087,93 @@
           </a:bodyPr>
           <a:lstStyle/>
           <a:p>
-            <a:pPr algn="l">
-              <a:lnSpc>
-                <a:spcPts val="2025"/>
-              </a:lnSpc>
-            </a:pPr>
-            <a:r>
-              <a:rPr sz="1350" b="1">
-                <a:solidFill>
-                  <a:schemeClr val="accent1"/>
-                </a:solidFill>
-                <a:latin typeface="+mn-lt"/>
-                <a:ea typeface="+mn-ea"/>
-              </a:rPr>
-              <a:t>수집 규칙</a:t>
-            </a:r>
-          </a:p>
-        </p:txBody>
-      </p:sp>
-      <p:sp>
-        <p:nvSpPr>
-          <p:cNvPr id="5" name="ul s4.1.1.1"/>
+            <a:pPr marL="342900" indent="-342900" algn="l">
+              <a:lnSpc>
+                <a:spcPts val="2700"/>
+              </a:lnSpc>
+              <a:buFont typeface="+mn-lt"/>
+              <a:buChar char="•"/>
+            </a:pPr>
+            <a:r>
+              <a:rPr sz="1800" b="0">
+                <a:solidFill>
+                  <a:schemeClr val="tx1"/>
+                </a:solidFill>
+                <a:latin typeface="+mn-lt"/>
+                <a:ea typeface="+mn-ea"/>
+              </a:rPr>
+              <a:t>슬라이드 한 장이 파일 한 개다</a:t>
+            </a:r>
+          </a:p>
+          <a:p>
+            <a:pPr marL="342900" indent="-342900" algn="l">
+              <a:lnSpc>
+                <a:spcPts val="2700"/>
+              </a:lnSpc>
+              <a:buFont typeface="+mn-lt"/>
+              <a:buChar char="•"/>
+            </a:pPr>
+            <a:r>
+              <a:rPr sz="1800" b="0">
+                <a:solidFill>
+                  <a:schemeClr val="tx1"/>
+                </a:solidFill>
+                <a:latin typeface="+mn-lt"/>
+                <a:ea typeface="+mn-ea"/>
+              </a:rPr>
+              <a:t>순서는 경로 사전순 — 숫자 접두가 순서를 만든다</a:t>
+            </a:r>
+          </a:p>
+          <a:p>
+            <a:pPr marL="342900" indent="-342900" algn="l">
+              <a:lnSpc>
+                <a:spcPts val="2700"/>
+              </a:lnSpc>
+              <a:buFont typeface="+mn-lt"/>
+              <a:buChar char="•"/>
+            </a:pPr>
+            <a:r>
+              <a:rPr sz="1800" b="0">
+                <a:solidFill>
+                  <a:schemeClr val="tx1"/>
+                </a:solidFill>
+                <a:latin typeface="+mn-lt"/>
+                <a:ea typeface="+mn-ea"/>
+              </a:rPr>
+              <a:t>밑줄로 시작하는 파일은 건너뛴다 (초안·보류)</a:t>
+            </a:r>
+          </a:p>
+          <a:p>
+            <a:pPr marL="342900" indent="-342900" algn="l">
+              <a:lnSpc>
+                <a:spcPts val="2700"/>
+              </a:lnSpc>
+              <a:buFont typeface="+mn-lt"/>
+              <a:buChar char="•"/>
+            </a:pPr>
+            <a:r>
+              <a:rPr sz="1800" b="0">
+                <a:solidFill>
+                  <a:schemeClr val="tx1"/>
+                </a:solidFill>
+                <a:latin typeface="+mn-lt"/>
+                <a:ea typeface="+mn-ea"/>
+              </a:rPr>
+              <a:t>하위 디렉토리는 챕터가 된다</a:t>
+            </a:r>
+          </a:p>
+        </p:txBody>
+      </p:sp>
+      <p:sp>
+        <p:nvSpPr>
+          <p:cNvPr id="6" name="text s4.1.1.1.0"/>
           <p:cNvSpPr txBox="1"/>
           <p:nvPr/>
         </p:nvSpPr>
         <p:spPr>
           <a:xfrm>
-            <a:off x="6324600" y="1963936"/>
-            <a:ext cx="5257800" cy="1371600"/>
+            <a:off x="6324600" y="3564136"/>
+            <a:ext cx="5257800" cy="257175"/>
           </a:xfrm>
           <a:prstGeom prst="rect">
             <a:avLst/>
@@ -3410,92 +4189,76 @@
           </a:bodyPr>
           <a:lstStyle/>
           <a:p>
-            <a:pPr marL="342900" indent="-342900" algn="l">
-              <a:lnSpc>
-                <a:spcPts val="2700"/>
-              </a:lnSpc>
-              <a:buFont typeface="+mn-lt"/>
-              <a:buChar char="•"/>
-            </a:pPr>
-            <a:r>
-              <a:rPr sz="1800" b="0">
+            <a:pPr algn="l">
+              <a:lnSpc>
+                <a:spcPts val="2025"/>
+              </a:lnSpc>
+            </a:pPr>
+            <a:r>
+              <a:rPr sz="1350" b="1">
+                <a:solidFill>
+                  <a:schemeClr val="accent1"/>
+                </a:solidFill>
+                <a:latin typeface="+mn-lt"/>
+                <a:ea typeface="+mn-ea"/>
+              </a:rPr>
+              <a:t>balpyo.json</a:t>
+            </a:r>
+          </a:p>
+        </p:txBody>
+      </p:sp>
+      <p:sp>
+        <p:nvSpPr>
+          <p:cNvPr id="7" name="p s4.1.1.1.1"/>
+          <p:cNvSpPr txBox="1"/>
+          <p:nvPr/>
+        </p:nvSpPr>
+        <p:spPr>
+          <a:xfrm>
+            <a:off x="6324600" y="3935611"/>
+            <a:ext cx="5257800" cy="571500"/>
+          </a:xfrm>
+          <a:prstGeom prst="rect">
+            <a:avLst/>
+          </a:prstGeom>
+          <a:noFill/>
+          <a:ln>
+            <a:noFill/>
+          </a:ln>
+        </p:spPr>
+        <p:txBody>
+          <a:bodyPr wrap="square" lIns="0" tIns="0" rIns="0" bIns="0" anchor="t">
+            <a:normAutofit/>
+          </a:bodyPr>
+          <a:lstStyle/>
+          <a:p>
+            <a:pPr algn="l">
+              <a:lnSpc>
+                <a:spcPts val="2250"/>
+              </a:lnSpc>
+            </a:pPr>
+            <a:r>
+              <a:rPr sz="1500" b="0">
                 <a:solidFill>
                   <a:schemeClr val="tx1"/>
                 </a:solidFill>
                 <a:latin typeface="+mn-lt"/>
                 <a:ea typeface="+mn-ea"/>
               </a:rPr>
-              <a:t>슬라이드 한 장이 파일 한 개다</a:t>
-            </a:r>
-          </a:p>
-          <a:p>
-            <a:pPr marL="342900" indent="-342900" algn="l">
-              <a:lnSpc>
-                <a:spcPts val="2700"/>
-              </a:lnSpc>
-              <a:buFont typeface="+mn-lt"/>
-              <a:buChar char="•"/>
-            </a:pPr>
-            <a:r>
-              <a:rPr sz="1800" b="0">
-                <a:solidFill>
-                  <a:schemeClr val="tx1"/>
-                </a:solidFill>
-                <a:latin typeface="+mn-lt"/>
-                <a:ea typeface="+mn-ea"/>
-              </a:rPr>
-              <a:t>순서는 경로 사전순 — 숫자 접두가 순서를 만든다</a:t>
-            </a:r>
-          </a:p>
-          <a:p>
-            <a:pPr marL="342900" indent="-342900" algn="l">
-              <a:lnSpc>
-                <a:spcPts val="2700"/>
-              </a:lnSpc>
-              <a:buFont typeface="+mn-lt"/>
-              <a:buChar char="•"/>
-            </a:pPr>
-            <a:r>
-              <a:rPr sz="1800" b="0">
-                <a:solidFill>
-                  <a:schemeClr val="tx1"/>
-                </a:solidFill>
-                <a:latin typeface="+mn-lt"/>
-                <a:ea typeface="+mn-ea"/>
-              </a:rPr>
-              <a:t>밑줄로 시작하는 파일은 건너뛴다 (초안·보류)</a:t>
-            </a:r>
-          </a:p>
-          <a:p>
-            <a:pPr marL="342900" indent="-342900" algn="l">
-              <a:lnSpc>
-                <a:spcPts val="2700"/>
-              </a:lnSpc>
-              <a:buFont typeface="+mn-lt"/>
-              <a:buChar char="•"/>
-            </a:pPr>
-            <a:r>
-              <a:rPr sz="1800" b="0">
-                <a:solidFill>
-                  <a:schemeClr val="tx1"/>
-                </a:solidFill>
-                <a:latin typeface="+mn-lt"/>
-                <a:ea typeface="+mn-ea"/>
-              </a:rPr>
-              <a:t>하위 디렉토리는 챕터가 된다</a:t>
-            </a:r>
-          </a:p>
-        </p:txBody>
-      </p:sp>
-      <p:sp>
-        <p:nvSpPr>
-          <p:cNvPr id="6" name="shape s4.2"/>
+              <a:t>제목 · 저자 · 언어 · 비율(16:9 · 4:3) · 테마 · 출력 경로 · 꼬리말 · 쪽 번호</a:t>
+            </a:r>
+          </a:p>
+        </p:txBody>
+      </p:sp>
+      <p:sp>
+        <p:nvSpPr>
+          <p:cNvPr id="8" name="shape s4.2"/>
           <p:cNvSpPr/>
           <p:nvPr/>
         </p:nvSpPr>
         <p:spPr>
           <a:xfrm>
-            <a:off x="609600" y="4021336"/>
+            <a:off x="609600" y="5438775"/>
             <a:ext cx="10972800" cy="809625"/>
           </a:xfrm>
           <a:prstGeom prst="roundRect">
@@ -3614,11 +4377,11 @@
         <p:spPr>
           <a:xfrm>
             <a:off x="609600" y="1478161"/>
-            <a:ext cx="3429000" cy="2095500"/>
+            <a:ext cx="3429000" cy="3710880"/>
           </a:xfrm>
           <a:prstGeom prst="roundRect">
             <a:avLst>
-              <a:gd name="adj" fmla="val 10909"/>
+              <a:gd name="adj" fmla="val 6667"/>
             </a:avLst>
           </a:prstGeom>
           <a:solidFill>
@@ -3641,7 +4404,7 @@
       </p:sp>
       <p:sp>
         <p:nvSpPr>
-          <p:cNvPr id="4" name="shape s5.1.0.0.0"/>
+          <p:cNvPr id="4" name="shape s5.1.0.0.0.0"/>
           <p:cNvSpPr/>
           <p:nvPr/>
         </p:nvSpPr>
@@ -3688,7 +4451,7 @@
       </p:sp>
       <p:sp>
         <p:nvSpPr>
-          <p:cNvPr id="5" name="p s5.1.0.0.1"/>
+          <p:cNvPr id="5" name="p s5.1.0.0.0.1"/>
           <p:cNvSpPr txBox="1"/>
           <p:nvPr/>
         </p:nvSpPr>
@@ -3731,18 +4494,61 @@
       </p:sp>
       <p:sp>
         <p:nvSpPr>
-          <p:cNvPr id="6" name="shape s5.1.1"/>
+          <p:cNvPr id="6" name="text s5.1.0.0.1"/>
+          <p:cNvSpPr txBox="1"/>
+          <p:nvPr/>
+        </p:nvSpPr>
+        <p:spPr>
+          <a:xfrm>
+            <a:off x="905024" y="4379268"/>
+            <a:ext cx="2838152" cy="514350"/>
+          </a:xfrm>
+          <a:prstGeom prst="rect">
+            <a:avLst/>
+          </a:prstGeom>
+          <a:noFill/>
+          <a:ln>
+            <a:noFill/>
+          </a:ln>
+        </p:spPr>
+        <p:txBody>
+          <a:bodyPr wrap="square" lIns="0" tIns="0" rIns="0" bIns="0" anchor="t">
+            <a:normAutofit/>
+          </a:bodyPr>
+          <a:lstStyle/>
+          <a:p>
+            <a:pPr algn="l">
+              <a:lnSpc>
+                <a:spcPts val="2025"/>
+              </a:lnSpc>
+            </a:pPr>
+            <a:r>
+              <a:rPr sz="1350" b="0">
+                <a:solidFill>
+                  <a:schemeClr val="tx2"/>
+                </a:solidFill>
+                <a:latin typeface="Noto Sans Mono"/>
+                <a:ea typeface="Noto Sans Mono CJK KR"/>
+              </a:rPr>
+              <a:t>&lt;row&gt; · &lt;col&gt; · &lt;grid&gt; · &lt;stack&gt;</a:t>
+            </a:r>
+          </a:p>
+        </p:txBody>
+      </p:sp>
+      <p:sp>
+        <p:nvSpPr>
+          <p:cNvPr id="7" name="shape s5.1.1"/>
           <p:cNvSpPr/>
           <p:nvPr/>
         </p:nvSpPr>
         <p:spPr>
           <a:xfrm>
             <a:off x="4381500" y="1478161"/>
-            <a:ext cx="3429000" cy="2095500"/>
+            <a:ext cx="3429000" cy="3710880"/>
           </a:xfrm>
           <a:prstGeom prst="roundRect">
             <a:avLst>
-              <a:gd name="adj" fmla="val 10909"/>
+              <a:gd name="adj" fmla="val 6667"/>
             </a:avLst>
           </a:prstGeom>
           <a:solidFill>
@@ -3765,7 +4571,7 @@
       </p:sp>
       <p:sp>
         <p:nvSpPr>
-          <p:cNvPr id="7" name="shape s5.1.1.0.0"/>
+          <p:cNvPr id="8" name="shape s5.1.1.0.0.0"/>
           <p:cNvSpPr/>
           <p:nvPr/>
         </p:nvSpPr>
@@ -3812,7 +4618,7 @@
       </p:sp>
       <p:sp>
         <p:nvSpPr>
-          <p:cNvPr id="8" name="p s5.1.1.0.1"/>
+          <p:cNvPr id="9" name="p s5.1.1.0.0.1"/>
           <p:cNvSpPr txBox="1"/>
           <p:nvPr/>
         </p:nvSpPr>
@@ -3855,18 +4661,61 @@
       </p:sp>
       <p:sp>
         <p:nvSpPr>
-          <p:cNvPr id="9" name="shape s5.1.2"/>
+          <p:cNvPr id="10" name="text s5.1.1.0.1"/>
+          <p:cNvSpPr txBox="1"/>
+          <p:nvPr/>
+        </p:nvSpPr>
+        <p:spPr>
+          <a:xfrm>
+            <a:off x="4676924" y="4636443"/>
+            <a:ext cx="2838152" cy="257175"/>
+          </a:xfrm>
+          <a:prstGeom prst="rect">
+            <a:avLst/>
+          </a:prstGeom>
+          <a:noFill/>
+          <a:ln>
+            <a:noFill/>
+          </a:ln>
+        </p:spPr>
+        <p:txBody>
+          <a:bodyPr wrap="square" lIns="0" tIns="0" rIns="0" bIns="0" anchor="t">
+            <a:normAutofit/>
+          </a:bodyPr>
+          <a:lstStyle/>
+          <a:p>
+            <a:pPr algn="l">
+              <a:lnSpc>
+                <a:spcPts val="2025"/>
+              </a:lnSpc>
+            </a:pPr>
+            <a:r>
+              <a:rPr sz="1350" b="0">
+                <a:solidFill>
+                  <a:schemeClr val="tx2"/>
+                </a:solidFill>
+                <a:latin typeface="Noto Sans Mono"/>
+                <a:ea typeface="Noto Sans Mono CJK KR"/>
+              </a:rPr>
+              <a:t>getBoundingClientRect</a:t>
+            </a:r>
+          </a:p>
+        </p:txBody>
+      </p:sp>
+      <p:sp>
+        <p:nvSpPr>
+          <p:cNvPr id="11" name="shape s5.1.2"/>
           <p:cNvSpPr/>
           <p:nvPr/>
         </p:nvSpPr>
         <p:spPr>
           <a:xfrm>
             <a:off x="8153400" y="1478161"/>
-            <a:ext cx="3429000" cy="2095500"/>
+            <a:ext cx="3429000" cy="3710880"/>
           </a:xfrm>
           <a:prstGeom prst="roundRect">
             <a:avLst>
-              <a:gd name="adj" fmla="val 10909"/>
+              <a:gd name="adj" fmla="val 6667"/>
             </a:avLst>
           </a:prstGeom>
           <a:solidFill>
@@ -3889,7 +4738,7 @@
       </p:sp>
       <p:sp>
         <p:nvSpPr>
-          <p:cNvPr id="10" name="shape s5.1.2.0.0"/>
+          <p:cNvPr id="12" name="shape s5.1.2.0.0.0"/>
           <p:cNvSpPr/>
           <p:nvPr/>
         </p:nvSpPr>
@@ -3936,7 +4785,7 @@
       </p:sp>
       <p:sp>
         <p:nvSpPr>
-          <p:cNvPr id="11" name="p s5.1.2.0.1"/>
+          <p:cNvPr id="13" name="p s5.1.2.0.0.1"/>
           <p:cNvSpPr txBox="1"/>
           <p:nvPr/>
         </p:nvSpPr>
@@ -3979,13 +4828,56 @@
       </p:sp>
       <p:sp>
         <p:nvSpPr>
-          <p:cNvPr id="12" name="shape s5.2"/>
+          <p:cNvPr id="14" name="text s5.1.2.0.1"/>
+          <p:cNvSpPr txBox="1"/>
+          <p:nvPr/>
+        </p:nvSpPr>
+        <p:spPr>
+          <a:xfrm>
+            <a:off x="8448824" y="4636443"/>
+            <a:ext cx="2838152" cy="257175"/>
+          </a:xfrm>
+          <a:prstGeom prst="rect">
+            <a:avLst/>
+          </a:prstGeom>
+          <a:noFill/>
+          <a:ln>
+            <a:noFill/>
+          </a:ln>
+        </p:spPr>
+        <p:txBody>
+          <a:bodyPr wrap="square" lIns="0" tIns="0" rIns="0" bIns="0" anchor="t">
+            <a:normAutofit/>
+          </a:bodyPr>
+          <a:lstStyle/>
+          <a:p>
+            <a:pPr algn="l">
+              <a:lnSpc>
+                <a:spcPts val="2025"/>
+              </a:lnSpc>
+            </a:pPr>
+            <a:r>
+              <a:rPr sz="1350" b="0">
+                <a:solidFill>
+                  <a:schemeClr val="tx2"/>
+                </a:solidFill>
+                <a:latin typeface="Noto Sans Mono"/>
+                <a:ea typeface="Noto Sans Mono CJK KR"/>
+              </a:rPr>
+              <a:t>a:off · a:ext</a:t>
+            </a:r>
+          </a:p>
+        </p:txBody>
+      </p:sp>
+      <p:sp>
+        <p:nvSpPr>
+          <p:cNvPr id="15" name="shape s5.2"/>
           <p:cNvSpPr/>
           <p:nvPr/>
         </p:nvSpPr>
         <p:spPr>
           <a:xfrm>
-            <a:off x="609600" y="3802261"/>
+            <a:off x="609600" y="5417641"/>
             <a:ext cx="10972800" cy="830759"/>
           </a:xfrm>
           <a:prstGeom prst="roundRect">
@@ -4103,7 +4995,7 @@
         </p:nvGraphicFramePr>
         <p:xfrm>
           <a:off x="609600" y="1478161"/>
-          <a:ext cx="10972800" cy="3543300"/>
+          <a:ext cx="10972800" cy="4048125"/>
         </p:xfrm>
         <a:graphic>
           <a:graphicData uri="http://schemas.openxmlformats.org/drawingml/2006/table">
@@ -4112,8 +5004,8 @@
                 <a:tableStyleId>{5940675A-B579-460E-94D1-54222C63F5DA}</a:tableStyleId>
               </a:tblPr>
               <a:tblGrid>
-                <a:gridCol w="5072360"/>
-                <a:gridCol w="5900440"/>
+                <a:gridCol w="4856857"/>
+                <a:gridCol w="6115943"/>
               </a:tblGrid>
               <a:tr h="509588">
                 <a:tc>
@@ -4739,7 +5631,7 @@
                   </a:tcPr>
                 </a:tc>
               </a:tr>
-              <a:tr h="509587">
+              <a:tr h="504825">
                 <a:tc>
                   <a:txBody>
                     <a:bodyPr/>
@@ -4845,53 +5737,112 @@
                   </a:tcPr>
                 </a:tc>
               </a:tr>
+              <a:tr h="509587">
+                <a:tc>
+                  <a:txBody>
+                    <a:bodyPr/>
+                    <a:lstStyle/>
+                    <a:p>
+                      <a:pPr algn="l">
+                        <a:lnSpc>
+                          <a:spcPts val="2700"/>
+                        </a:lnSpc>
+                      </a:pPr>
+                      <a:r>
+                        <a:rPr sz="1800" b="0">
+                          <a:solidFill>
+                            <a:schemeClr val="tx1"/>
+                          </a:solidFill>
+                          <a:latin typeface="+mn-lt"/>
+                          <a:ea typeface="+mn-ea"/>
+                        </a:rPr>
+                        <a:t>&lt;chart&gt; · &lt;point&gt;</a:t>
+                      </a:r>
+                    </a:p>
+                  </a:txBody>
+                  <a:tcPr marL="114300" marR="114300" marT="76200" marB="76200" anchor="t">
+                    <a:lnL w="9525">
+                      <a:solidFill>
+                        <a:schemeClr val="tx2"/>
+                      </a:solidFill>
+                      <a:prstDash val="solid"/>
+                    </a:lnL>
+                    <a:lnR w="9525">
+                      <a:solidFill>
+                        <a:schemeClr val="tx2"/>
+                      </a:solidFill>
+                      <a:prstDash val="solid"/>
+                    </a:lnR>
+                    <a:lnT w="9525">
+                      <a:solidFill>
+                        <a:schemeClr val="tx2"/>
+                      </a:solidFill>
+                      <a:prstDash val="solid"/>
+                    </a:lnT>
+                    <a:lnB w="9525">
+                      <a:solidFill>
+                        <a:schemeClr val="tx2"/>
+                      </a:solidFill>
+                      <a:prstDash val="solid"/>
+                    </a:lnB>
+                    <a:noFill/>
+                  </a:tcPr>
+                </a:tc>
+                <a:tc>
+                  <a:txBody>
+                    <a:bodyPr/>
+                    <a:lstStyle/>
+                    <a:p>
+                      <a:pPr algn="l">
+                        <a:lnSpc>
+                          <a:spcPts val="2700"/>
+                        </a:lnSpc>
+                      </a:pPr>
+                      <a:r>
+                        <a:rPr sz="1800" b="0">
+                          <a:solidFill>
+                            <a:schemeClr val="tx1"/>
+                          </a:solidFill>
+                          <a:latin typeface="+mn-lt"/>
+                          <a:ea typeface="+mn-ea"/>
+                        </a:rPr>
+                        <a:t>도형 + 텍스트로 풀린다 — 막대 하나가 도형 하나</a:t>
+                      </a:r>
+                    </a:p>
+                  </a:txBody>
+                  <a:tcPr marL="114300" marR="114300" marT="76200" marB="76200" anchor="t">
+                    <a:lnL w="9525">
+                      <a:solidFill>
+                        <a:schemeClr val="tx2"/>
+                      </a:solidFill>
+                      <a:prstDash val="solid"/>
+                    </a:lnL>
+                    <a:lnR w="9525">
+                      <a:solidFill>
+                        <a:schemeClr val="tx2"/>
+                      </a:solidFill>
+                      <a:prstDash val="solid"/>
+                    </a:lnR>
+                    <a:lnT w="9525">
+                      <a:solidFill>
+                        <a:schemeClr val="tx2"/>
+                      </a:solidFill>
+                      <a:prstDash val="solid"/>
+                    </a:lnT>
+                    <a:lnB w="9525">
+                      <a:solidFill>
+                        <a:schemeClr val="tx2"/>
+                      </a:solidFill>
+                      <a:prstDash val="solid"/>
+                    </a:lnB>
+                    <a:noFill/>
+                  </a:tcPr>
+                </a:tc>
+              </a:tr>
             </a:tbl>
           </a:graphicData>
         </a:graphic>
       </p:graphicFrame>
-      <p:sp>
-        <p:nvSpPr>
-          <p:cNvPr id="4" name="text s6.2"/>
-          <p:cNvSpPr txBox="1"/>
-          <p:nvPr/>
-        </p:nvSpPr>
-        <p:spPr>
-          <a:xfrm>
-            <a:off x="609600" y="5250061"/>
-            <a:ext cx="10972800" cy="239911"/>
-          </a:xfrm>
-          <a:prstGeom prst="rect">
-            <a:avLst/>
-          </a:prstGeom>
-          <a:noFill/>
-          <a:ln>
-            <a:noFill/>
-          </a:ln>
-        </p:spPr>
-        <p:txBody>
-          <a:bodyPr wrap="square" lIns="0" tIns="0" rIns="0" bIns="0" anchor="t">
-            <a:normAutofit/>
-          </a:bodyPr>
-          <a:lstStyle/>
-          <a:p>
-            <a:pPr algn="l">
-              <a:lnSpc>
-                <a:spcPts val="1890"/>
-              </a:lnSpc>
-            </a:pPr>
-            <a:r>
-              <a:rPr sz="1350" b="0">
-                <a:solidFill>
-                  <a:schemeClr val="tx2"/>
-                </a:solidFill>
-                <a:latin typeface="+mn-lt"/>
-                <a:ea typeface="+mn-ea"/>
-              </a:rPr>
-              <a:t>PowerPoint에서 글자를 고칠 수 있고, 표는 셀을 클릭해 행을 더할 수 있다. 이 목록이 그 약속이다.</a:t>
-            </a:r>
-          </a:p>
-        </p:txBody>
-      </p:sp>
     </p:spTree>
   </p:cSld>
   <p:clrMapOvr>
@@ -4969,11 +5920,11 @@
         <p:spPr>
           <a:xfrm>
             <a:off x="609600" y="1478161"/>
-            <a:ext cx="2103090" cy="838200"/>
+            <a:ext cx="2103090" cy="1143000"/>
           </a:xfrm>
           <a:prstGeom prst="roundRect">
             <a:avLst>
-              <a:gd name="adj" fmla="val 13636"/>
+              <a:gd name="adj" fmla="val 10000"/>
             </a:avLst>
           </a:prstGeom>
           <a:solidFill>
@@ -4994,11 +5945,11 @@
           <a:p>
             <a:pPr algn="ctr">
               <a:lnSpc>
-                <a:spcPts val="1800"/>
-              </a:lnSpc>
-            </a:pPr>
-            <a:r>
-              <a:rPr sz="1200" b="0">
+                <a:spcPts val="2250"/>
+              </a:lnSpc>
+            </a:pPr>
+            <a:r>
+              <a:rPr sz="1500" b="0">
                 <a:solidFill>
                   <a:schemeClr val="bg1"/>
                 </a:solidFill>
@@ -5019,11 +5970,11 @@
         <p:spPr>
           <a:xfrm>
             <a:off x="2826990" y="1478161"/>
-            <a:ext cx="2103090" cy="838200"/>
+            <a:ext cx="2103090" cy="1143000"/>
           </a:xfrm>
           <a:prstGeom prst="roundRect">
             <a:avLst>
-              <a:gd name="adj" fmla="val 13636"/>
+              <a:gd name="adj" fmla="val 10000"/>
             </a:avLst>
           </a:prstGeom>
           <a:solidFill>
@@ -5044,11 +5995,11 @@
           <a:p>
             <a:pPr algn="ctr">
               <a:lnSpc>
-                <a:spcPts val="1800"/>
-              </a:lnSpc>
-            </a:pPr>
-            <a:r>
-              <a:rPr sz="1200" b="0">
+                <a:spcPts val="2250"/>
+              </a:lnSpc>
+            </a:pPr>
+            <a:r>
+              <a:rPr sz="1500" b="0">
                 <a:solidFill>
                   <a:schemeClr val="tx1"/>
                 </a:solidFill>
@@ -5069,11 +6020,11 @@
         <p:spPr>
           <a:xfrm>
             <a:off x="5044380" y="1478161"/>
-            <a:ext cx="2103090" cy="838200"/>
+            <a:ext cx="2103090" cy="1143000"/>
           </a:xfrm>
           <a:prstGeom prst="roundRect">
             <a:avLst>
-              <a:gd name="adj" fmla="val 13636"/>
+              <a:gd name="adj" fmla="val 10000"/>
             </a:avLst>
           </a:prstGeom>
           <a:solidFill>
@@ -5094,11 +6045,11 @@
           <a:p>
             <a:pPr algn="ctr">
               <a:lnSpc>
-                <a:spcPts val="1800"/>
-              </a:lnSpc>
-            </a:pPr>
-            <a:r>
-              <a:rPr sz="1200" b="0">
+                <a:spcPts val="2250"/>
+              </a:lnSpc>
+            </a:pPr>
+            <a:r>
+              <a:rPr sz="1500" b="0">
                 <a:solidFill>
                   <a:schemeClr val="bg1"/>
                 </a:solidFill>
@@ -5119,11 +6070,11 @@
         <p:spPr>
           <a:xfrm>
             <a:off x="7261771" y="1478161"/>
-            <a:ext cx="2103090" cy="838200"/>
+            <a:ext cx="2103090" cy="1143000"/>
           </a:xfrm>
           <a:prstGeom prst="roundRect">
             <a:avLst>
-              <a:gd name="adj" fmla="val 13636"/>
+              <a:gd name="adj" fmla="val 10000"/>
             </a:avLst>
           </a:prstGeom>
           <a:solidFill>
@@ -5144,11 +6095,11 @@
           <a:p>
             <a:pPr algn="ctr">
               <a:lnSpc>
-                <a:spcPts val="1800"/>
-              </a:lnSpc>
-            </a:pPr>
-            <a:r>
-              <a:rPr sz="1200" b="0">
+                <a:spcPts val="2250"/>
+              </a:lnSpc>
+            </a:pPr>
+            <a:r>
+              <a:rPr sz="1500" b="0">
                 <a:solidFill>
                   <a:schemeClr val="tx1"/>
                 </a:solidFill>
@@ -5169,11 +6120,11 @@
         <p:spPr>
           <a:xfrm>
             <a:off x="9479161" y="1478161"/>
-            <a:ext cx="2103239" cy="838200"/>
+            <a:ext cx="2103239" cy="1143000"/>
           </a:xfrm>
           <a:prstGeom prst="roundRect">
             <a:avLst>
-              <a:gd name="adj" fmla="val 13636"/>
+              <a:gd name="adj" fmla="val 10000"/>
             </a:avLst>
           </a:prstGeom>
           <a:solidFill>
@@ -5194,11 +6145,11 @@
           <a:p>
             <a:pPr algn="ctr">
               <a:lnSpc>
-                <a:spcPts val="1800"/>
-              </a:lnSpc>
-            </a:pPr>
-            <a:r>
-              <a:rPr sz="1200" b="0">
+                <a:spcPts val="2250"/>
+              </a:lnSpc>
+            </a:pPr>
+            <a:r>
+              <a:rPr sz="1500" b="0">
                 <a:solidFill>
                   <a:schemeClr val="bg1"/>
                 </a:solidFill>
@@ -5212,14 +6163,45 @@
       </p:sp>
       <p:sp>
         <p:nvSpPr>
-          <p:cNvPr id="8" name="text s7.2.0.0"/>
+          <p:cNvPr id="8" name="shape s7.2.0"/>
+          <p:cNvSpPr/>
+          <p:nvPr/>
+        </p:nvSpPr>
+        <p:spPr>
+          <a:xfrm>
+            <a:off x="609600" y="2849761"/>
+            <a:ext cx="5314950" cy="3398639"/>
+          </a:xfrm>
+          <a:prstGeom prst="roundRect">
+            <a:avLst>
+              <a:gd name="adj" fmla="val 6726"/>
+            </a:avLst>
+          </a:prstGeom>
+          <a:solidFill>
+            <a:schemeClr val="bg2"/>
+          </a:solidFill>
+          <a:ln>
+            <a:noFill/>
+          </a:ln>
+        </p:spPr>
+        <p:txBody>
+          <a:bodyPr wrap="square" lIns="342900" tIns="342900" rIns="342900" bIns="342900" anchor="t">
+            <a:normAutofit/>
+          </a:bodyPr>
+          <a:lstStyle/>
+          <a:p/>
+        </p:txBody>
+      </p:sp>
+      <p:sp>
+        <p:nvSpPr>
+          <p:cNvPr id="9" name="text s7.2.0.0.0"/>
           <p:cNvSpPr txBox="1"/>
           <p:nvPr/>
         </p:nvSpPr>
         <p:spPr>
           <a:xfrm>
-            <a:off x="609600" y="2544961"/>
-            <a:ext cx="5257800" cy="257175"/>
+            <a:off x="1019324" y="3259485"/>
+            <a:ext cx="4495502" cy="257175"/>
           </a:xfrm>
           <a:prstGeom prst="rect">
             <a:avLst/>
@@ -5255,14 +6237,14 @@
       </p:sp>
       <p:sp>
         <p:nvSpPr>
-          <p:cNvPr id="9" name="ul s7.2.0.1"/>
+          <p:cNvPr id="10" name="ul s7.2.0.0.1"/>
           <p:cNvSpPr txBox="1"/>
           <p:nvPr/>
         </p:nvSpPr>
         <p:spPr>
           <a:xfrm>
-            <a:off x="609600" y="2916436"/>
-            <a:ext cx="5257800" cy="2057400"/>
+            <a:off x="1019324" y="3630960"/>
+            <a:ext cx="4495502" cy="1571625"/>
           </a:xfrm>
           <a:prstGeom prst="rect">
             <a:avLst/>
@@ -5280,32 +6262,32 @@
           <a:p>
             <a:pPr marL="342900" indent="-342900" algn="l">
               <a:lnSpc>
-                <a:spcPts val="2700"/>
+                <a:spcPts val="2475"/>
               </a:lnSpc>
               <a:buFont typeface="+mn-lt"/>
               <a:buChar char="•"/>
             </a:pPr>
             <a:r>
-              <a:rPr sz="1800" b="0">
+              <a:rPr sz="1650" b="0">
                 <a:solidFill>
                   <a:schemeClr val="tx1"/>
                 </a:solidFill>
                 <a:latin typeface="+mn-lt"/>
                 <a:ea typeface="+mn-ea"/>
               </a:rPr>
-              <a:t>tokens.json — 색 5 · 폰트 3 · 공간 6 · 반경 3 · 그림자 1</a:t>
+              <a:t>tokens.json — 색 · 폰트 · 공간 · 반경 · 그림자</a:t>
             </a:r>
           </a:p>
           <a:p>
             <a:pPr marL="342900" indent="-342900" algn="l">
               <a:lnSpc>
-                <a:spcPts val="2700"/>
+                <a:spcPts val="2475"/>
               </a:lnSpc>
               <a:buFont typeface="+mn-lt"/>
               <a:buChar char="•"/>
             </a:pPr>
             <a:r>
-              <a:rPr sz="1800" b="0">
+              <a:rPr sz="1650" b="0">
                 <a:solidFill>
                   <a:schemeClr val="tx1"/>
                 </a:solidFill>
@@ -5318,13 +6300,13 @@
           <a:p>
             <a:pPr marL="342900" indent="-342900" algn="l">
               <a:lnSpc>
-                <a:spcPts val="2700"/>
+                <a:spcPts val="2475"/>
               </a:lnSpc>
               <a:buFont typeface="+mn-lt"/>
               <a:buChar char="•"/>
             </a:pPr>
             <a:r>
-              <a:rPr sz="1800" b="0">
+              <a:rPr sz="1650" b="0">
                 <a:solidFill>
                   <a:schemeClr val="tx1"/>
                 </a:solidFill>
@@ -5338,14 +6320,45 @@
       </p:sp>
       <p:sp>
         <p:nvSpPr>
-          <p:cNvPr id="10" name="text s7.2.1.0"/>
+          <p:cNvPr id="11" name="shape s7.2.1"/>
+          <p:cNvSpPr/>
+          <p:nvPr/>
+        </p:nvSpPr>
+        <p:spPr>
+          <a:xfrm>
+            <a:off x="6267450" y="2849761"/>
+            <a:ext cx="5314950" cy="3398639"/>
+          </a:xfrm>
+          <a:prstGeom prst="roundRect">
+            <a:avLst>
+              <a:gd name="adj" fmla="val 6726"/>
+            </a:avLst>
+          </a:prstGeom>
+          <a:solidFill>
+            <a:schemeClr val="bg2"/>
+          </a:solidFill>
+          <a:ln>
+            <a:noFill/>
+          </a:ln>
+        </p:spPr>
+        <p:txBody>
+          <a:bodyPr wrap="square" lIns="342900" tIns="342900" rIns="342900" bIns="342900" anchor="t">
+            <a:normAutofit/>
+          </a:bodyPr>
+          <a:lstStyle/>
+          <a:p/>
+        </p:txBody>
+      </p:sp>
+      <p:sp>
+        <p:nvSpPr>
+          <p:cNvPr id="12" name="text s7.2.1.0.0.0"/>
           <p:cNvSpPr txBox="1"/>
           <p:nvPr/>
         </p:nvSpPr>
         <p:spPr>
           <a:xfrm>
-            <a:off x="6324600" y="2544961"/>
-            <a:ext cx="5257800" cy="257175"/>
+            <a:off x="6677174" y="3259485"/>
+            <a:ext cx="4495502" cy="257175"/>
           </a:xfrm>
           <a:prstGeom prst="rect">
             <a:avLst/>
@@ -5381,14 +6394,14 @@
       </p:sp>
       <p:sp>
         <p:nvSpPr>
-          <p:cNvPr id="11" name="p s7.2.1.1"/>
+          <p:cNvPr id="13" name="p s7.2.1.0.0.1"/>
           <p:cNvSpPr txBox="1"/>
           <p:nvPr/>
         </p:nvSpPr>
         <p:spPr>
           <a:xfrm>
-            <a:off x="6324600" y="2916436"/>
-            <a:ext cx="5257800" cy="857250"/>
+            <a:off x="6677174" y="3630960"/>
+            <a:ext cx="4495502" cy="628650"/>
           </a:xfrm>
           <a:prstGeom prst="rect">
             <a:avLst/>
@@ -5406,18 +6419,61 @@
           <a:p>
             <a:pPr algn="l">
               <a:lnSpc>
-                <a:spcPts val="2250"/>
-              </a:lnSpc>
-            </a:pPr>
-            <a:r>
-              <a:rPr sz="1500" b="0">
+                <a:spcPts val="2475"/>
+              </a:lnSpc>
+            </a:pPr>
+            <a:r>
+              <a:rPr sz="1650" b="0">
                 <a:solidFill>
                   <a:schemeClr val="tx1"/>
                 </a:solidFill>
                 <a:latin typeface="+mn-lt"/>
                 <a:ea typeface="+mn-ea"/>
               </a:rPr>
-              <a:t>토큰으로 쓴 색은 웹에서 CSS 변수로, PPTX에서 a:schemeClr로 남는다. 리터럴만 srgbClr가 된다 — PowerPoint에서 테마 색을 바꾸면 덱이 따라온다.</a:t>
+              <a:t>토큰으로 쓴 색은 웹에서 CSS 변수로, PPTX에서 a:schemeClr로 남는다. 리터럴만 srgbClr가 된다.</a:t>
+            </a:r>
+          </a:p>
+        </p:txBody>
+      </p:sp>
+      <p:sp>
+        <p:nvSpPr>
+          <p:cNvPr id="14" name="text s7.2.1.0.1"/>
+          <p:cNvSpPr txBox="1"/>
+          <p:nvPr/>
+        </p:nvSpPr>
+        <p:spPr>
+          <a:xfrm>
+            <a:off x="6677174" y="5194846"/>
+            <a:ext cx="4495502" cy="643830"/>
+          </a:xfrm>
+          <a:prstGeom prst="rect">
+            <a:avLst/>
+          </a:prstGeom>
+          <a:noFill/>
+          <a:ln>
+            <a:noFill/>
+          </a:ln>
+        </p:spPr>
+        <p:txBody>
+          <a:bodyPr wrap="square" lIns="0" tIns="0" rIns="0" bIns="0" anchor="t">
+            <a:normAutofit/>
+          </a:bodyPr>
+          <a:lstStyle/>
+          <a:p>
+            <a:pPr algn="l">
+              <a:lnSpc>
+                <a:spcPts val="2535"/>
+              </a:lnSpc>
+            </a:pPr>
+            <a:r>
+              <a:rPr sz="1950" b="1">
+                <a:solidFill>
+                  <a:schemeClr val="accent1"/>
+                </a:solidFill>
+                <a:latin typeface="+mj-lt"/>
+                <a:ea typeface="+mj-ea"/>
+              </a:rPr>
+              <a:t>→ PowerPoint에서 테마 색을 바꾸면 덱이 따라온다</a:t>
             </a:r>
           </a:p>
         </p:txBody>
@@ -5494,14 +6550,45 @@
       </p:sp>
       <p:sp>
         <p:nvSpPr>
-          <p:cNvPr id="3" name="text s8.1.0"/>
+          <p:cNvPr id="3" name="shape s8.1.0"/>
+          <p:cNvSpPr/>
+          <p:nvPr/>
+        </p:nvSpPr>
+        <p:spPr>
+          <a:xfrm>
+            <a:off x="609600" y="1478161"/>
+            <a:ext cx="5372100" cy="4770239"/>
+          </a:xfrm>
+          <a:prstGeom prst="roundRect">
+            <a:avLst>
+              <a:gd name="adj" fmla="val 4792"/>
+            </a:avLst>
+          </a:prstGeom>
+          <a:solidFill>
+            <a:schemeClr val="bg2"/>
+          </a:solidFill>
+          <a:ln>
+            <a:noFill/>
+          </a:ln>
+        </p:spPr>
+        <p:txBody>
+          <a:bodyPr wrap="square" lIns="342900" tIns="342900" rIns="342900" bIns="342900" anchor="t">
+            <a:normAutofit/>
+          </a:bodyPr>
+          <a:lstStyle/>
+          <a:p/>
+        </p:txBody>
+      </p:sp>
+      <p:sp>
+        <p:nvSpPr>
+          <p:cNvPr id="4" name="text s8.1.0.0.0.0"/>
           <p:cNvSpPr txBox="1"/>
           <p:nvPr/>
         </p:nvSpPr>
         <p:spPr>
           <a:xfrm>
-            <a:off x="609600" y="1478161"/>
-            <a:ext cx="5372100" cy="257175"/>
+            <a:off x="1019324" y="1887885"/>
+            <a:ext cx="4552652" cy="257175"/>
           </a:xfrm>
           <a:prstGeom prst="rect">
             <a:avLst/>
@@ -5537,14 +6624,14 @@
       </p:sp>
       <p:sp>
         <p:nvSpPr>
-          <p:cNvPr id="4" name="ul s8.1.1"/>
+          <p:cNvPr id="5" name="ul s8.1.0.0.0.1"/>
           <p:cNvSpPr txBox="1"/>
           <p:nvPr/>
         </p:nvSpPr>
         <p:spPr>
           <a:xfrm>
-            <a:off x="609600" y="1963936"/>
-            <a:ext cx="5372100" cy="1028700"/>
+            <a:off x="1019324" y="2373660"/>
+            <a:ext cx="4552652" cy="1371600"/>
           </a:xfrm>
           <a:prstGeom prst="rect">
             <a:avLst/>
@@ -5613,21 +6700,21 @@
                 <a:latin typeface="+mn-lt"/>
                 <a:ea typeface="+mn-ea"/>
               </a:rPr>
-              <a:t>줄이 어디서 접히는지는 각 엔진의 몫이다</a:t>
-            </a:r>
-          </a:p>
-        </p:txBody>
-      </p:sp>
-      <p:sp>
-        <p:nvSpPr>
-          <p:cNvPr id="5" name="text s8.2.0"/>
+              <a:t>문서 순서가 곧 도형 순서다</a:t>
+            </a:r>
+          </a:p>
+        </p:txBody>
+      </p:sp>
+      <p:sp>
+        <p:nvSpPr>
+          <p:cNvPr id="6" name="text s8.1.0.0.1"/>
           <p:cNvSpPr txBox="1"/>
           <p:nvPr/>
         </p:nvSpPr>
         <p:spPr>
           <a:xfrm>
-            <a:off x="6210300" y="1478161"/>
-            <a:ext cx="5372100" cy="257175"/>
+            <a:off x="1019324" y="5598765"/>
+            <a:ext cx="4552652" cy="239911"/>
           </a:xfrm>
           <a:prstGeom prst="rect">
             <a:avLst/>
@@ -5645,32 +6732,63 @@
           <a:p>
             <a:pPr algn="l">
               <a:lnSpc>
-                <a:spcPts val="2025"/>
-              </a:lnSpc>
-            </a:pPr>
-            <a:r>
-              <a:rPr sz="1350" b="1">
-                <a:solidFill>
-                  <a:schemeClr val="accent1"/>
-                </a:solidFill>
-                <a:latin typeface="+mn-lt"/>
-                <a:ea typeface="+mn-ea"/>
-              </a:rPr>
-              <a:t>무엇이 판정하는가</a:t>
-            </a:r>
-          </a:p>
-        </p:txBody>
-      </p:sp>
-      <p:sp>
-        <p:nvSpPr>
-          <p:cNvPr id="6" name="ul s8.2.1"/>
+                <a:spcPts val="1890"/>
+              </a:lnSpc>
+            </a:pPr>
+            <a:r>
+              <a:rPr sz="1350" b="0">
+                <a:solidFill>
+                  <a:schemeClr val="tx2"/>
+                </a:solidFill>
+                <a:latin typeface="+mn-lt"/>
+                <a:ea typeface="+mn-ea"/>
+              </a:rPr>
+              <a:t>줄이 어디서 접히는지는 각 엔진의 몫이다 — 약속 밖이다.</a:t>
+            </a:r>
+          </a:p>
+        </p:txBody>
+      </p:sp>
+      <p:sp>
+        <p:nvSpPr>
+          <p:cNvPr id="7" name="shape s8.2.0"/>
+          <p:cNvSpPr/>
+          <p:nvPr/>
+        </p:nvSpPr>
+        <p:spPr>
+          <a:xfrm>
+            <a:off x="6210300" y="1478161"/>
+            <a:ext cx="5372100" cy="4770239"/>
+          </a:xfrm>
+          <a:prstGeom prst="roundRect">
+            <a:avLst>
+              <a:gd name="adj" fmla="val 4792"/>
+            </a:avLst>
+          </a:prstGeom>
+          <a:solidFill>
+            <a:schemeClr val="accent1"/>
+          </a:solidFill>
+          <a:ln>
+            <a:noFill/>
+          </a:ln>
+        </p:spPr>
+        <p:txBody>
+          <a:bodyPr wrap="square" lIns="342900" tIns="342900" rIns="342900" bIns="342900" anchor="t">
+            <a:normAutofit/>
+          </a:bodyPr>
+          <a:lstStyle/>
+          <a:p/>
+        </p:txBody>
+      </p:sp>
+      <p:sp>
+        <p:nvSpPr>
+          <p:cNvPr id="8" name="text s8.2.0.0.0.0"/>
           <p:cNvSpPr txBox="1"/>
           <p:nvPr/>
         </p:nvSpPr>
         <p:spPr>
           <a:xfrm>
-            <a:off x="6210300" y="1963936"/>
-            <a:ext cx="5372100" cy="1028700"/>
+            <a:off x="6620024" y="1887885"/>
+            <a:ext cx="4552652" cy="257175"/>
           </a:xfrm>
           <a:prstGeom prst="rect">
             <a:avLst/>
@@ -5686,6 +6804,49 @@
           </a:bodyPr>
           <a:lstStyle/>
           <a:p>
+            <a:pPr algn="l">
+              <a:lnSpc>
+                <a:spcPts val="2025"/>
+              </a:lnSpc>
+            </a:pPr>
+            <a:r>
+              <a:rPr sz="1350" b="1">
+                <a:solidFill>
+                  <a:schemeClr val="bg1"/>
+                </a:solidFill>
+                <a:latin typeface="+mn-lt"/>
+                <a:ea typeface="+mn-ea"/>
+              </a:rPr>
+              <a:t>무엇이 판정하는가</a:t>
+            </a:r>
+          </a:p>
+        </p:txBody>
+      </p:sp>
+      <p:sp>
+        <p:nvSpPr>
+          <p:cNvPr id="9" name="ul s8.2.0.0.0.1"/>
+          <p:cNvSpPr txBox="1"/>
+          <p:nvPr/>
+        </p:nvSpPr>
+        <p:spPr>
+          <a:xfrm>
+            <a:off x="6620024" y="2373660"/>
+            <a:ext cx="4552652" cy="1371600"/>
+          </a:xfrm>
+          <a:prstGeom prst="rect">
+            <a:avLst/>
+          </a:prstGeom>
+          <a:noFill/>
+          <a:ln>
+            <a:noFill/>
+          </a:ln>
+        </p:spPr>
+        <p:txBody>
+          <a:bodyPr wrap="square" lIns="0" tIns="0" rIns="0" bIns="0" anchor="t">
+            <a:normAutofit/>
+          </a:bodyPr>
+          <a:lstStyle/>
+          <a:p>
             <a:pPr marL="342900" indent="-342900" algn="l">
               <a:lnSpc>
                 <a:spcPts val="2700"/>
@@ -5696,7 +6857,7 @@
             <a:r>
               <a:rPr sz="1800" b="0">
                 <a:solidFill>
-                  <a:schemeClr val="tx1"/>
+                  <a:schemeClr val="bg1"/>
                 </a:solidFill>
                 <a:latin typeface="+mn-lt"/>
                 <a:ea typeface="+mn-ea"/>
@@ -5715,7 +6876,7 @@
             <a:r>
               <a:rPr sz="1800" b="0">
                 <a:solidFill>
-                  <a:schemeClr val="tx1"/>
+                  <a:schemeClr val="bg1"/>
                 </a:solidFill>
                 <a:latin typeface="+mn-lt"/>
                 <a:ea typeface="+mn-ea"/>
@@ -5734,12 +6895,55 @@
             <a:r>
               <a:rPr sz="1800" b="0">
                 <a:solidFill>
-                  <a:schemeClr val="tx1"/>
+                  <a:schemeClr val="bg1"/>
                 </a:solidFill>
                 <a:latin typeface="+mn-lt"/>
                 <a:ea typeface="+mn-ea"/>
               </a:rPr>
               <a:t>같은 입력은 같은 바이트를 낸다</a:t>
+            </a:r>
+          </a:p>
+        </p:txBody>
+      </p:sp>
+      <p:sp>
+        <p:nvSpPr>
+          <p:cNvPr id="10" name="text s8.2.0.0.1"/>
+          <p:cNvSpPr txBox="1"/>
+          <p:nvPr/>
+        </p:nvSpPr>
+        <p:spPr>
+          <a:xfrm>
+            <a:off x="6620024" y="5598765"/>
+            <a:ext cx="4552652" cy="239911"/>
+          </a:xfrm>
+          <a:prstGeom prst="rect">
+            <a:avLst/>
+          </a:prstGeom>
+          <a:noFill/>
+          <a:ln>
+            <a:noFill/>
+          </a:ln>
+        </p:spPr>
+        <p:txBody>
+          <a:bodyPr wrap="square" lIns="0" tIns="0" rIns="0" bIns="0" anchor="t">
+            <a:normAutofit/>
+          </a:bodyPr>
+          <a:lstStyle/>
+          <a:p>
+            <a:pPr algn="l">
+              <a:lnSpc>
+                <a:spcPts val="1890"/>
+              </a:lnSpc>
+            </a:pPr>
+            <a:r>
+              <a:rPr sz="1350" b="0">
+                <a:solidFill>
+                  <a:schemeClr val="bg1"/>
+                </a:solidFill>
+                <a:latin typeface="+mn-lt"/>
+                <a:ea typeface="+mn-ea"/>
+              </a:rPr>
+              <a:t>셋 다 go test ./... 한 줄에 들어 있다.</a:t>
             </a:r>
           </a:p>
         </p:txBody>

</xml_diff>

<commit_message>
doc: regenerate the showcase PPTX after the wrap, tint and chevron fixes
</commit_message>
<xml_diff>
--- a/examples/showcase/decks/balpyo-intro/balpyo-소개.pptx
+++ b/examples/showcase/decks/balpyo-intro/balpyo-소개.pptx
@@ -1156,8 +1156,8 @@
         </p:nvSpPr>
         <p:spPr>
           <a:xfrm>
-            <a:off x="4621857" y="609600"/>
-            <a:ext cx="2948136" cy="257175"/>
+            <a:off x="4508748" y="609600"/>
+            <a:ext cx="3174504" cy="257175"/>
           </a:xfrm>
           <a:prstGeom prst="rect">
             <a:avLst/>
@@ -1168,7 +1168,7 @@
           </a:ln>
         </p:spPr>
         <p:txBody>
-          <a:bodyPr wrap="square" lIns="0" tIns="0" rIns="0" bIns="0" anchor="t">
+          <a:bodyPr wrap="none" lIns="0" tIns="0" rIns="0" bIns="0" anchor="t">
             <a:normAutofit/>
           </a:bodyPr>
           <a:lstStyle/>
@@ -1201,8 +1201,8 @@
         </p:nvSpPr>
         <p:spPr>
           <a:xfrm>
-            <a:off x="4836170" y="1095375"/>
-            <a:ext cx="2519660" cy="1005780"/>
+            <a:off x="4694932" y="1095375"/>
+            <a:ext cx="2802136" cy="1005780"/>
           </a:xfrm>
           <a:prstGeom prst="rect">
             <a:avLst/>
@@ -1213,7 +1213,7 @@
           </a:ln>
         </p:spPr>
         <p:txBody>
-          <a:bodyPr wrap="square" lIns="0" tIns="0" rIns="0" bIns="0" anchor="t">
+          <a:bodyPr wrap="none" lIns="0" tIns="0" rIns="0" bIns="0" anchor="t">
             <a:normAutofit/>
           </a:bodyPr>
           <a:lstStyle/>
@@ -1246,8 +1246,8 @@
         </p:nvSpPr>
         <p:spPr>
           <a:xfrm>
-            <a:off x="2014389" y="2329755"/>
-            <a:ext cx="8163223" cy="445740"/>
+            <a:off x="1795611" y="2329755"/>
+            <a:ext cx="8600629" cy="445740"/>
           </a:xfrm>
           <a:prstGeom prst="rect">
             <a:avLst/>
@@ -1258,7 +1258,7 @@
           </a:ln>
         </p:spPr>
         <p:txBody>
-          <a:bodyPr wrap="square" lIns="0" tIns="0" rIns="0" bIns="0" anchor="t">
+          <a:bodyPr wrap="none" lIns="0" tIns="0" rIns="0" bIns="0" anchor="t">
             <a:normAutofit/>
           </a:bodyPr>
           <a:lstStyle/>
@@ -1291,8 +1291,8 @@
         </p:nvSpPr>
         <p:spPr>
           <a:xfrm>
-            <a:off x="5130701" y="5436989"/>
-            <a:ext cx="1930598" cy="342900"/>
+            <a:off x="5084266" y="5436989"/>
+            <a:ext cx="2023467" cy="342900"/>
           </a:xfrm>
           <a:prstGeom prst="rect">
             <a:avLst/>
@@ -1303,7 +1303,7 @@
           </a:ln>
         </p:spPr>
         <p:txBody>
-          <a:bodyPr wrap="square" lIns="0" tIns="0" rIns="0" bIns="0" anchor="t">
+          <a:bodyPr wrap="none" lIns="0" tIns="0" rIns="0" bIns="0" anchor="t">
             <a:normAutofit/>
           </a:bodyPr>
           <a:lstStyle/>
@@ -1336,8 +1336,8 @@
         </p:nvSpPr>
         <p:spPr>
           <a:xfrm>
-            <a:off x="4523482" y="6008489"/>
-            <a:ext cx="3145036" cy="239911"/>
+            <a:off x="4407694" y="6008489"/>
+            <a:ext cx="3376464" cy="239911"/>
           </a:xfrm>
           <a:prstGeom prst="rect">
             <a:avLst/>
@@ -1348,7 +1348,7 @@
           </a:ln>
         </p:spPr>
         <p:txBody>
-          <a:bodyPr wrap="square" lIns="0" tIns="0" rIns="0" bIns="0" anchor="t">
+          <a:bodyPr wrap="none" lIns="0" tIns="0" rIns="0" bIns="0" anchor="t">
             <a:normAutofit/>
           </a:bodyPr>
           <a:lstStyle/>
@@ -2537,7 +2537,7 @@
         <p:spPr>
           <a:xfrm>
             <a:off x="6620024" y="2373660"/>
-            <a:ext cx="4552652" cy="1028700"/>
+            <a:ext cx="4552652" cy="1371600"/>
           </a:xfrm>
           <a:prstGeom prst="rect">
             <a:avLst/>
@@ -3147,7 +3147,7 @@
           </a:xfrm>
           <a:prstGeom prst="chevron">
             <a:avLst>
-              <a:gd name="adj" fmla="val 193750"/>
+              <a:gd name="adj" fmla="val 193751"/>
             </a:avLst>
           </a:prstGeom>
           <a:solidFill>
@@ -3161,7 +3161,7 @@
           </a:ln>
         </p:spPr>
         <p:txBody>
-          <a:bodyPr wrap="square" lIns="-1328738" tIns="0" rIns="-1328738" bIns="0" anchor="t">
+          <a:bodyPr wrap="square" lIns="0" tIns="0" rIns="0" bIns="0" anchor="t">
             <a:normAutofit/>
           </a:bodyPr>
           <a:lstStyle/>
@@ -3224,7 +3224,7 @@
           </a:xfrm>
           <a:prstGeom prst="chevron">
             <a:avLst>
-              <a:gd name="adj" fmla="val 193750"/>
+              <a:gd name="adj" fmla="val 193751"/>
             </a:avLst>
           </a:prstGeom>
           <a:solidFill>
@@ -3238,7 +3238,7 @@
           </a:ln>
         </p:spPr>
         <p:txBody>
-          <a:bodyPr wrap="square" lIns="-1328738" tIns="0" rIns="-1328738" bIns="0" anchor="t">
+          <a:bodyPr wrap="square" lIns="0" tIns="0" rIns="0" bIns="0" anchor="t">
             <a:normAutofit/>
           </a:bodyPr>
           <a:lstStyle/>
@@ -3301,7 +3301,7 @@
           </a:xfrm>
           <a:prstGeom prst="chevron">
             <a:avLst>
-              <a:gd name="adj" fmla="val 193750"/>
+              <a:gd name="adj" fmla="val 193751"/>
             </a:avLst>
           </a:prstGeom>
           <a:solidFill>
@@ -3315,7 +3315,7 @@
           </a:ln>
         </p:spPr>
         <p:txBody>
-          <a:bodyPr wrap="square" lIns="-1328738" tIns="0" rIns="-1328738" bIns="0" anchor="t">
+          <a:bodyPr wrap="square" lIns="0" tIns="0" rIns="0" bIns="0" anchor="t">
             <a:normAutofit/>
           </a:bodyPr>
           <a:lstStyle/>
@@ -3378,7 +3378,7 @@
           </a:xfrm>
           <a:prstGeom prst="chevron">
             <a:avLst>
-              <a:gd name="adj" fmla="val 193750"/>
+              <a:gd name="adj" fmla="val 193751"/>
             </a:avLst>
           </a:prstGeom>
           <a:solidFill>
@@ -3392,7 +3392,7 @@
           </a:ln>
         </p:spPr>
         <p:txBody>
-          <a:bodyPr wrap="square" lIns="-1328738" tIns="0" rIns="-1328738" bIns="0" anchor="t">
+          <a:bodyPr wrap="square" lIns="0" tIns="0" rIns="0" bIns="0" anchor="t">
             <a:normAutofit/>
           </a:bodyPr>
           <a:lstStyle/>
@@ -3688,7 +3688,7 @@
         <p:spPr>
           <a:xfrm>
             <a:off x="6677174" y="3688110"/>
-            <a:ext cx="4495502" cy="1257300"/>
+            <a:ext cx="4495502" cy="1571625"/>
           </a:xfrm>
           <a:prstGeom prst="rect">
             <a:avLst/>
@@ -4458,7 +4458,7 @@
         <p:spPr>
           <a:xfrm>
             <a:off x="905024" y="2345085"/>
-            <a:ext cx="2838152" cy="571500"/>
+            <a:ext cx="2838152" cy="857250"/>
           </a:xfrm>
           <a:prstGeom prst="rect">
             <a:avLst/>
@@ -5004,8 +5004,8 @@
                 <a:tableStyleId>{5940675A-B579-460E-94D1-54222C63F5DA}</a:tableStyleId>
               </a:tblPr>
               <a:tblGrid>
-                <a:gridCol w="4856857"/>
-                <a:gridCol w="6115943"/>
+                <a:gridCol w="4850755"/>
+                <a:gridCol w="6122045"/>
               </a:tblGrid>
               <a:tr h="509588">
                 <a:tc>

</xml_diff>

<commit_message>
doc: regenerate the showcase after the layout, tint and slot-default changes
</commit_message>
<xml_diff>
--- a/examples/showcase/decks/balpyo-intro/balpyo-소개.pptx
+++ b/examples/showcase/decks/balpyo-intro/balpyo-소개.pptx
@@ -1156,7 +1156,7 @@
         </p:nvSpPr>
         <p:spPr>
           <a:xfrm>
-            <a:off x="4508748" y="609600"/>
+            <a:off x="4508748" y="1368772"/>
             <a:ext cx="3174504" cy="257175"/>
           </a:xfrm>
           <a:prstGeom prst="rect">
@@ -1201,7 +1201,7 @@
         </p:nvSpPr>
         <p:spPr>
           <a:xfrm>
-            <a:off x="4694932" y="1095375"/>
+            <a:off x="4694932" y="1854547"/>
             <a:ext cx="2802136" cy="1005780"/>
           </a:xfrm>
           <a:prstGeom prst="rect">
@@ -1246,7 +1246,7 @@
         </p:nvSpPr>
         <p:spPr>
           <a:xfrm>
-            <a:off x="1795611" y="2329755"/>
+            <a:off x="1795611" y="3088928"/>
             <a:ext cx="8600629" cy="445740"/>
           </a:xfrm>
           <a:prstGeom prst="rect">
@@ -1291,7 +1291,7 @@
         </p:nvSpPr>
         <p:spPr>
           <a:xfrm>
-            <a:off x="5084266" y="5436989"/>
+            <a:off x="5084266" y="4677668"/>
             <a:ext cx="2023467" cy="342900"/>
           </a:xfrm>
           <a:prstGeom prst="rect">
@@ -1336,7 +1336,7 @@
         </p:nvSpPr>
         <p:spPr>
           <a:xfrm>
-            <a:off x="4407694" y="6008489"/>
+            <a:off x="4407694" y="5249168"/>
             <a:ext cx="3376464" cy="239911"/>
           </a:xfrm>
           <a:prstGeom prst="rect">

</xml_diff>

<commit_message>
chore: Regenerate example decks
</commit_message>
<xml_diff>
--- a/examples/showcase/decks/balpyo-intro/balpyo-소개.pptx
+++ b/examples/showcase/decks/balpyo-intro/balpyo-소개.pptx
@@ -7066,4 +7066,116 @@
     </a:fmtScheme>
   </a:themeElements>
 </a:theme>
+</file>
+
+<file path=ppt/theme/theme2.xml><?xml version="1.0" encoding="utf-8"?>
+<a:theme xmlns:a="http://schemas.openxmlformats.org/drawingml/2006/main" name="minimal">
+  <a:themeElements>
+    <a:clrScheme name="minimal">
+      <a:dk1>
+        <a:srgbClr val="1A1A1A"/>
+      </a:dk1>
+      <a:lt1>
+        <a:srgbClr val="FFFFFF"/>
+      </a:lt1>
+      <a:dk2>
+        <a:srgbClr val="6B7280"/>
+      </a:dk2>
+      <a:lt2>
+        <a:srgbClr val="F3F4F6"/>
+      </a:lt2>
+      <a:accent1>
+        <a:srgbClr val="0F65F9"/>
+      </a:accent1>
+      <a:accent2>
+        <a:srgbClr val="0E8174"/>
+      </a:accent2>
+      <a:accent3>
+        <a:srgbClr val="15803D"/>
+      </a:accent3>
+      <a:accent4>
+        <a:srgbClr val="B45309"/>
+      </a:accent4>
+      <a:accent5>
+        <a:srgbClr val="DC2626"/>
+      </a:accent5>
+      <a:accent6>
+        <a:srgbClr val="9333EA"/>
+      </a:accent6>
+      <a:hlink>
+        <a:srgbClr val="0F65F9"/>
+      </a:hlink>
+      <a:folHlink>
+        <a:srgbClr val="0F65F9"/>
+      </a:folHlink>
+    </a:clrScheme>
+    <a:fontScheme name="minimal">
+      <a:majorFont>
+        <a:latin typeface="Noto Sans"/>
+        <a:ea typeface="Noto Sans CJK KR"/>
+        <a:cs typeface=""/>
+      </a:majorFont>
+      <a:minorFont>
+        <a:latin typeface="Noto Sans"/>
+        <a:ea typeface="Noto Sans CJK KR"/>
+        <a:cs typeface=""/>
+      </a:minorFont>
+    </a:fontScheme>
+    <a:fmtScheme name="minimal">
+      <a:fillStyleLst>
+        <a:solidFill>
+          <a:schemeClr val="phClr"/>
+        </a:solidFill>
+        <a:solidFill>
+          <a:schemeClr val="phClr"/>
+        </a:solidFill>
+        <a:solidFill>
+          <a:schemeClr val="phClr"/>
+        </a:solidFill>
+      </a:fillStyleLst>
+      <a:lnStyleLst>
+        <a:ln w="9525" cap="flat" cmpd="sng" algn="ctr">
+          <a:solidFill>
+            <a:schemeClr val="phClr"/>
+          </a:solidFill>
+          <a:prstDash val="solid"/>
+        </a:ln>
+        <a:ln w="19050" cap="flat" cmpd="sng" algn="ctr">
+          <a:solidFill>
+            <a:schemeClr val="phClr"/>
+          </a:solidFill>
+          <a:prstDash val="solid"/>
+        </a:ln>
+        <a:ln w="28575" cap="flat" cmpd="sng" algn="ctr">
+          <a:solidFill>
+            <a:schemeClr val="phClr"/>
+          </a:solidFill>
+          <a:prstDash val="solid"/>
+        </a:ln>
+      </a:lnStyleLst>
+      <a:effectStyleLst>
+        <a:effectStyle>
+          <a:effectLst/>
+        </a:effectStyle>
+        <a:effectStyle>
+          <a:effectLst/>
+        </a:effectStyle>
+        <a:effectStyle>
+          <a:effectLst/>
+        </a:effectStyle>
+      </a:effectStyleLst>
+      <a:bgFillStyleLst>
+        <a:solidFill>
+          <a:schemeClr val="phClr"/>
+        </a:solidFill>
+        <a:solidFill>
+          <a:schemeClr val="phClr"/>
+        </a:solidFill>
+        <a:solidFill>
+          <a:schemeClr val="phClr"/>
+        </a:solidFill>
+      </a:bgFillStyleLst>
+    </a:fmtScheme>
+  </a:themeElements>
+</a:theme>
 </file>
</xml_diff>

<commit_message>
doc: showcase the ec2-intro deck and re-render examples/showcase
</commit_message>
<xml_diff>
--- a/examples/showcase/decks/balpyo-intro/balpyo-소개.pptx
+++ b/examples/showcase/decks/balpyo-intro/balpyo-소개.pptx
@@ -1156,8 +1156,8 @@
         </p:nvSpPr>
         <p:spPr>
           <a:xfrm>
-            <a:off x="4508748" y="1368772"/>
-            <a:ext cx="3174504" cy="257175"/>
+            <a:off x="4251573" y="1368772"/>
+            <a:ext cx="3688854" cy="257175"/>
           </a:xfrm>
           <a:prstGeom prst="rect">
             <a:avLst/>
@@ -1179,7 +1179,7 @@
               </a:lnSpc>
             </a:pPr>
             <a:r>
-              <a:rPr sz="1350" b="1">
+              <a:rPr sz="1350" b="1" spc="135" cap="all">
                 <a:solidFill>
                   <a:schemeClr val="accent1"/>
                 </a:solidFill>
@@ -1614,7 +1614,7 @@
               </a:lnSpc>
             </a:pPr>
             <a:r>
-              <a:rPr sz="1350" b="1">
+              <a:rPr sz="1350" b="1" spc="135" cap="all">
                 <a:solidFill>
                   <a:schemeClr val="accent1"/>
                 </a:solidFill>
@@ -1828,7 +1828,7 @@
               </a:lnSpc>
             </a:pPr>
             <a:r>
-              <a:rPr sz="1350" b="1">
+              <a:rPr sz="1350" b="1" spc="135" cap="all">
                 <a:solidFill>
                   <a:schemeClr val="accent1"/>
                 </a:solidFill>
@@ -2335,7 +2335,7 @@
               </a:lnSpc>
             </a:pPr>
             <a:r>
-              <a:rPr sz="1350" b="1">
+              <a:rPr sz="1350" b="1" spc="135" cap="all">
                 <a:solidFill>
                   <a:schemeClr val="accent1"/>
                 </a:solidFill>
@@ -2516,7 +2516,7 @@
               </a:lnSpc>
             </a:pPr>
             <a:r>
-              <a:rPr sz="1350" b="1">
+              <a:rPr sz="1350" b="1" spc="135" cap="all">
                 <a:solidFill>
                   <a:schemeClr val="accent1"/>
                 </a:solidFill>
@@ -2765,7 +2765,7 @@
               </a:lnSpc>
             </a:pPr>
             <a:r>
-              <a:rPr sz="1350" b="1">
+              <a:rPr sz="1350" b="1" spc="135" cap="all">
                 <a:solidFill>
                   <a:schemeClr val="accent1"/>
                 </a:solidFill>
@@ -2925,7 +2925,7 @@
               </a:lnSpc>
             </a:pPr>
             <a:r>
-              <a:rPr sz="1350" b="1">
+              <a:rPr sz="1350" b="1" spc="135" cap="all">
                 <a:solidFill>
                   <a:schemeClr val="bg1"/>
                 </a:solidFill>
@@ -4050,7 +4050,7 @@
               </a:lnSpc>
             </a:pPr>
             <a:r>
-              <a:rPr sz="1350" b="1">
+              <a:rPr sz="1350" b="1" spc="135" cap="all">
                 <a:solidFill>
                   <a:schemeClr val="accent1"/>
                 </a:solidFill>
@@ -4195,7 +4195,7 @@
               </a:lnSpc>
             </a:pPr>
             <a:r>
-              <a:rPr sz="1350" b="1">
+              <a:rPr sz="1350" b="1" spc="135" cap="all">
                 <a:solidFill>
                   <a:schemeClr val="accent1"/>
                 </a:solidFill>
@@ -6223,7 +6223,7 @@
               </a:lnSpc>
             </a:pPr>
             <a:r>
-              <a:rPr sz="1350" b="1">
+              <a:rPr sz="1350" b="1" spc="135" cap="all">
                 <a:solidFill>
                   <a:schemeClr val="accent1"/>
                 </a:solidFill>
@@ -6380,7 +6380,7 @@
               </a:lnSpc>
             </a:pPr>
             <a:r>
-              <a:rPr sz="1350" b="1">
+              <a:rPr sz="1350" b="1" spc="135" cap="all">
                 <a:solidFill>
                   <a:schemeClr val="accent1"/>
                 </a:solidFill>
@@ -6610,7 +6610,7 @@
               </a:lnSpc>
             </a:pPr>
             <a:r>
-              <a:rPr sz="1350" b="1">
+              <a:rPr sz="1350" b="1" spc="135" cap="all">
                 <a:solidFill>
                   <a:schemeClr val="accent1"/>
                 </a:solidFill>
@@ -6810,7 +6810,7 @@
               </a:lnSpc>
             </a:pPr>
             <a:r>
-              <a:rPr sz="1350" b="1">
+              <a:rPr sz="1350" b="1" spc="135" cap="all">
                 <a:solidFill>
                   <a:schemeClr val="bg1"/>
                 </a:solidFill>

</xml_diff>

<commit_message>
doc: re-render showcase with the shallower default chevron notch
</commit_message>
<xml_diff>
--- a/examples/showcase/decks/balpyo-intro/balpyo-소개.pptx
+++ b/examples/showcase/decks/balpyo-intro/balpyo-소개.pptx
@@ -3147,7 +3147,7 @@
           </a:xfrm>
           <a:prstGeom prst="chevron">
             <a:avLst>
-              <a:gd name="adj" fmla="val 193751"/>
+              <a:gd name="adj" fmla="val 77500"/>
             </a:avLst>
           </a:prstGeom>
           <a:solidFill>
@@ -3224,7 +3224,7 @@
           </a:xfrm>
           <a:prstGeom prst="chevron">
             <a:avLst>
-              <a:gd name="adj" fmla="val 193751"/>
+              <a:gd name="adj" fmla="val 77500"/>
             </a:avLst>
           </a:prstGeom>
           <a:solidFill>
@@ -3301,7 +3301,7 @@
           </a:xfrm>
           <a:prstGeom prst="chevron">
             <a:avLst>
-              <a:gd name="adj" fmla="val 193751"/>
+              <a:gd name="adj" fmla="val 77500"/>
             </a:avLst>
           </a:prstGeom>
           <a:solidFill>
@@ -3378,7 +3378,7 @@
           </a:xfrm>
           <a:prstGeom prst="chevron">
             <a:avLst>
-              <a:gd name="adj" fmla="val 193751"/>
+              <a:gd name="adj" fmla="val 77500"/>
             </a:avLst>
           </a:prstGeom>
           <a:solidFill>

</xml_diff>